<commit_message>
docs(slide): chèn ảnh demo dashboard vào Slide 15 + điền ngày bảo vệ ở Slide 1
- Slide 15: thêm ảnh chụp dashboard replay V8.5 (kịch bản DoS) — hoàn thành mục A/B
  trong CAN_LAM_THEM_VA_CHINH_SUA.md
- Slide 1: điền "Hà Nội, 7 / 2026" thay placeholder [tháng] / [năm]

Co-Authored-By: Claude Opus 4.8 <noreply@anthropic.com>
</commit_message>
<xml_diff>
--- a/BAO_VE_TOT_NGHIEP/Slide_Bao_Ve_HUST.pptx
+++ b/BAO_VE_TOT_NGHIEP/Slide_Bao_Ve_HUST.pptx
@@ -5,33 +5,33 @@
     <p:sldMasterId id="2147483658" r:id="rId1"/>
   </p:sldMasterIdLst>
   <p:notesMasterIdLst>
-    <p:notesMasterId r:id="rId15"/>
+    <p:notesMasterId r:id="rId23"/>
   </p:notesMasterIdLst>
   <p:handoutMasterIdLst>
-    <p:handoutMasterId r:id="rId16"/>
+    <p:handoutMasterId r:id="rId24"/>
   </p:handoutMasterIdLst>
   <p:sldIdLst>
-    <p:sldId id="256" r:id="rId8"/>
-    <p:sldId id="257" r:id="rId9"/>
-    <p:sldId id="258" r:id="rId10"/>
-    <p:sldId id="259" r:id="rId11"/>
-    <p:sldId id="260" r:id="rId12"/>
-    <p:sldId id="261" r:id="rId13"/>
-    <p:sldId id="262" r:id="rId14"/>
-    <p:sldId id="263" r:id="rId7"/>
-    <p:sldId id="264" r:id="rId6"/>
-    <p:sldId id="265" r:id="rId5"/>
-    <p:sldId id="266" r:id="rId4"/>
-    <p:sldId id="267" r:id="rId3"/>
-    <p:sldId id="268" r:id="rId2"/>
-    <p:sldId id="269" r:id="rId21"/>
-    <p:sldId id="270" r:id="rId22"/>
-    <p:sldId id="271" r:id="rId23"/>
-    <p:sldId id="272" r:id="rId24"/>
-    <p:sldId id="273" r:id="rId25"/>
-    <p:sldId id="274" r:id="rId26"/>
-    <p:sldId id="275" r:id="rId27"/>
-    <p:sldId id="276" r:id="rId28"/>
+    <p:sldId id="256" r:id="rId2"/>
+    <p:sldId id="257" r:id="rId3"/>
+    <p:sldId id="258" r:id="rId4"/>
+    <p:sldId id="259" r:id="rId5"/>
+    <p:sldId id="260" r:id="rId6"/>
+    <p:sldId id="261" r:id="rId7"/>
+    <p:sldId id="262" r:id="rId8"/>
+    <p:sldId id="263" r:id="rId9"/>
+    <p:sldId id="264" r:id="rId10"/>
+    <p:sldId id="265" r:id="rId11"/>
+    <p:sldId id="266" r:id="rId12"/>
+    <p:sldId id="267" r:id="rId13"/>
+    <p:sldId id="268" r:id="rId14"/>
+    <p:sldId id="269" r:id="rId15"/>
+    <p:sldId id="270" r:id="rId16"/>
+    <p:sldId id="271" r:id="rId17"/>
+    <p:sldId id="272" r:id="rId18"/>
+    <p:sldId id="273" r:id="rId19"/>
+    <p:sldId id="274" r:id="rId20"/>
+    <p:sldId id="275" r:id="rId21"/>
+    <p:sldId id="276" r:id="rId22"/>
   </p:sldIdLst>
   <p:sldSz cx="9144000" cy="6858000" type="screen4x3"/>
   <p:notesSz cx="6858000" cy="9144000"/>
@@ -232,7 +232,7 @@
           <a:p>
             <a:fld id="{48B45424-6BAC-416C-8F6C-5F9DE854A36B}" type="datetimeFigureOut">
               <a:rPr lang="en-US" smtClean="0"/>
-              <a:t>12/12/2022</a:t>
+              <a:t>7/10/2026</a:t>
             </a:fld>
             <a:endParaRPr lang="en-US"/>
           </a:p>
@@ -410,7 +410,7 @@
           <a:p>
             <a:fld id="{6B733702-C25A-40B9-9167-54BAA79B29B0}" type="datetimeFigureOut">
               <a:rPr lang="en-US" smtClean="0"/>
-              <a:t>12/12/2022</a:t>
+              <a:t>7/10/2026</a:t>
             </a:fld>
             <a:endParaRPr lang="en-US"/>
           </a:p>
@@ -798,7 +798,7 @@
             <a:fld id="{F70EAA40-3A53-4A3D-924A-D38F1059C7D5}" type="datetime1">
               <a:rPr lang="en-US" smtClean="0"/>
               <a:pPr/>
-              <a:t>12/12/2022</a:t>
+              <a:t>7/10/2026</a:t>
             </a:fld>
             <a:endParaRPr lang="en-US"/>
           </a:p>
@@ -1387,7 +1387,7 @@
             <a:fld id="{F70EAA40-3A53-4A3D-924A-D38F1059C7D5}" type="datetime1">
               <a:rPr lang="en-US" smtClean="0"/>
               <a:pPr/>
-              <a:t>12/12/2022</a:t>
+              <a:t>7/10/2026</a:t>
             </a:fld>
             <a:endParaRPr lang="en-US"/>
           </a:p>
@@ -1579,7 +1579,7 @@
             <a:fld id="{F70EAA40-3A53-4A3D-924A-D38F1059C7D5}" type="datetime1">
               <a:rPr lang="en-US" smtClean="0"/>
               <a:pPr/>
-              <a:t>12/12/2022</a:t>
+              <a:t>7/10/2026</a:t>
             </a:fld>
             <a:endParaRPr lang="en-US"/>
           </a:p>
@@ -1919,7 +1919,7 @@
             <a:fld id="{F70EAA40-3A53-4A3D-924A-D38F1059C7D5}" type="datetime1">
               <a:rPr lang="en-US" smtClean="0"/>
               <a:pPr/>
-              <a:t>12/12/2022</a:t>
+              <a:t>7/10/2026</a:t>
             </a:fld>
             <a:endParaRPr lang="en-US"/>
           </a:p>
@@ -2246,7 +2246,7 @@
             <a:fld id="{F70EAA40-3A53-4A3D-924A-D38F1059C7D5}" type="datetime1">
               <a:rPr lang="en-US" smtClean="0"/>
               <a:pPr/>
-              <a:t>12/12/2022</a:t>
+              <a:t>7/10/2026</a:t>
             </a:fld>
             <a:endParaRPr lang="en-US"/>
           </a:p>
@@ -2586,7 +2586,7 @@
             <a:fld id="{F70EAA40-3A53-4A3D-924A-D38F1059C7D5}" type="datetime1">
               <a:rPr lang="en-US" smtClean="0"/>
               <a:pPr/>
-              <a:t>12/12/2022</a:t>
+              <a:t>7/10/2026</a:t>
             </a:fld>
             <a:endParaRPr lang="en-US"/>
           </a:p>
@@ -3027,7 +3027,7 @@
             <a:fld id="{F70EAA40-3A53-4A3D-924A-D38F1059C7D5}" type="datetime1">
               <a:rPr lang="en-US" smtClean="0"/>
               <a:pPr/>
-              <a:t>12/12/2022</a:t>
+              <a:t>7/10/2026</a:t>
             </a:fld>
             <a:endParaRPr lang="en-US"/>
           </a:p>
@@ -3367,7 +3367,7 @@
             <a:fld id="{F70EAA40-3A53-4A3D-924A-D38F1059C7D5}" type="datetime1">
               <a:rPr lang="en-US" smtClean="0"/>
               <a:pPr/>
-              <a:t>12/12/2022</a:t>
+              <a:t>7/10/2026</a:t>
             </a:fld>
             <a:endParaRPr lang="en-US"/>
           </a:p>
@@ -3956,7 +3956,7 @@
             <a:fld id="{F70EAA40-3A53-4A3D-924A-D38F1059C7D5}" type="datetime1">
               <a:rPr lang="en-US" smtClean="0"/>
               <a:pPr/>
-              <a:t>12/12/2022</a:t>
+              <a:t>7/10/2026</a:t>
             </a:fld>
             <a:endParaRPr lang="en-US"/>
           </a:p>
@@ -4397,7 +4397,7 @@
             <a:fld id="{F70EAA40-3A53-4A3D-924A-D38F1059C7D5}" type="datetime1">
               <a:rPr lang="en-US" smtClean="0"/>
               <a:pPr/>
-              <a:t>12/12/2022</a:t>
+              <a:t>7/10/2026</a:t>
             </a:fld>
             <a:endParaRPr lang="en-US"/>
           </a:p>
@@ -4852,7 +4852,7 @@
 </file>
 
 <file path=ppt/slides/slide1.xml><?xml version="1.0" encoding="utf-8"?>
-<p:sld xmlns:a="http://schemas.openxmlformats.org/drawingml/2006/main" xmlns:p="http://schemas.openxmlformats.org/presentationml/2006/main" xmlns:r="http://schemas.openxmlformats.org/officeDocument/2006/relationships">
+<p:sld xmlns:a="http://schemas.openxmlformats.org/drawingml/2006/main" xmlns:r="http://schemas.openxmlformats.org/officeDocument/2006/relationships" xmlns:p="http://schemas.openxmlformats.org/presentationml/2006/main">
   <p:cSld>
     <p:spTree>
       <p:nvGrpSpPr>
@@ -4860,7 +4860,14 @@
         <p:cNvGrpSpPr/>
         <p:nvPr/>
       </p:nvGrpSpPr>
-      <p:grpSpPr/>
+      <p:grpSpPr>
+        <a:xfrm>
+          <a:off x="0" y="0"/>
+          <a:ext cx="0" cy="0"/>
+          <a:chOff x="0" y="0"/>
+          <a:chExt cx="0" cy="0"/>
+        </a:xfrm>
+      </p:grpSpPr>
       <p:sp>
         <p:nvSpPr>
           <p:cNvPr id="2" name="TextBox 1"/>
@@ -4878,7 +4885,7 @@
           <a:noFill/>
         </p:spPr>
         <p:txBody>
-          <a:bodyPr wrap="square" lIns="50800" rIns="50800" tIns="25400" bIns="25400">
+          <a:bodyPr wrap="square" lIns="50800" tIns="25400" rIns="50800" bIns="25400">
             <a:spAutoFit/>
           </a:bodyPr>
           <a:lstStyle/>
@@ -4921,7 +4928,7 @@
           <a:noFill/>
         </p:spPr>
         <p:txBody>
-          <a:bodyPr wrap="square" lIns="50800" rIns="50800" tIns="25400" bIns="25400">
+          <a:bodyPr wrap="square" lIns="50800" tIns="25400" rIns="50800" bIns="25400">
             <a:spAutoFit/>
           </a:bodyPr>
           <a:lstStyle/>
@@ -4956,7 +4963,7 @@
         <p:spPr>
           <a:xfrm>
             <a:off x="1005840" y="2514600"/>
-            <a:ext cx="7132320" cy="1645920"/>
+            <a:ext cx="7132320" cy="851515"/>
           </a:xfrm>
           <a:prstGeom prst="rect">
             <a:avLst/>
@@ -4964,7 +4971,7 @@
           <a:noFill/>
         </p:spPr>
         <p:txBody>
-          <a:bodyPr wrap="square" lIns="50800" rIns="50800" tIns="25400" bIns="25400">
+          <a:bodyPr wrap="square" lIns="50800" tIns="25400" rIns="50800" bIns="25400">
             <a:spAutoFit/>
           </a:bodyPr>
           <a:lstStyle/>
@@ -4979,7 +4986,7 @@
               <a:buNone/>
             </a:pPr>
             <a:r>
-              <a:rPr sz="2600" b="1" i="0">
+              <a:rPr sz="2600" b="1" i="0" dirty="0">
                 <a:solidFill>
                   <a:srgbClr val="FFFFFF"/>
                 </a:solidFill>
@@ -4987,7 +4994,45 @@
               </a:rPr>
               <a:t>PHÁT TRIỂN HỆ THỐNG PHÁT HIỆN TẤN CÔNG MẠNG</a:t>
             </a:r>
-          </a:p>
+            <a:r>
+              <a:rPr lang="en-US" sz="2600" b="1" i="0" dirty="0">
+                <a:solidFill>
+                  <a:srgbClr val="FFFFFF"/>
+                </a:solidFill>
+                <a:latin typeface="Calibri"/>
+              </a:rPr>
+              <a:t> BẰNG PHÁT HIỆN BẤT THƯỜNG</a:t>
+            </a:r>
+            <a:endParaRPr sz="2600" b="1" i="0" dirty="0">
+              <a:solidFill>
+                <a:srgbClr val="FFFFFF"/>
+              </a:solidFill>
+              <a:latin typeface="Calibri"/>
+            </a:endParaRPr>
+          </a:p>
+        </p:txBody>
+      </p:sp>
+      <p:sp>
+        <p:nvSpPr>
+          <p:cNvPr id="5" name="TextBox 4"/>
+          <p:cNvSpPr txBox="1"/>
+          <p:nvPr/>
+        </p:nvSpPr>
+        <p:spPr>
+          <a:xfrm>
+            <a:off x="914400" y="4709160"/>
+            <a:ext cx="7315200" cy="1074653"/>
+          </a:xfrm>
+          <a:prstGeom prst="rect">
+            <a:avLst/>
+          </a:prstGeom>
+          <a:noFill/>
+        </p:spPr>
+        <p:txBody>
+          <a:bodyPr wrap="square" lIns="50800" tIns="25400" rIns="50800" bIns="25400">
+            <a:spAutoFit/>
+          </a:bodyPr>
+          <a:lstStyle/>
           <a:p>
             <a:pPr algn="ctr">
               <a:spcBef>
@@ -4999,38 +5044,87 @@
               <a:buNone/>
             </a:pPr>
             <a:r>
-              <a:rPr sz="2000" b="0" i="0">
-                <a:solidFill>
-                  <a:srgbClr val="C9D4E6"/>
-                </a:solidFill>
-                <a:latin typeface="Calibri"/>
-              </a:rPr>
-              <a:t>bằng phát hiện bất thường</a:t>
-            </a:r>
-          </a:p>
-        </p:txBody>
-      </p:sp>
-      <p:sp>
-        <p:nvSpPr>
-          <p:cNvPr id="5" name="TextBox 4"/>
-          <p:cNvSpPr txBox="1"/>
-          <p:nvPr/>
-        </p:nvSpPr>
-        <p:spPr>
-          <a:xfrm>
-            <a:off x="914400" y="4709160"/>
-            <a:ext cx="7315200" cy="1463040"/>
-          </a:xfrm>
-          <a:prstGeom prst="rect">
-            <a:avLst/>
-          </a:prstGeom>
-          <a:noFill/>
-        </p:spPr>
-        <p:txBody>
-          <a:bodyPr wrap="square" lIns="50800" rIns="50800" tIns="25400" bIns="25400">
-            <a:spAutoFit/>
-          </a:bodyPr>
-          <a:lstStyle/>
+              <a:rPr sz="1400" b="0" i="0" dirty="0">
+                <a:solidFill>
+                  <a:srgbClr val="FFFFFF"/>
+                </a:solidFill>
+                <a:latin typeface="Calibri"/>
+              </a:rPr>
+              <a:t>Sinh </a:t>
+            </a:r>
+            <a:r>
+              <a:rPr sz="1400" b="0" i="0" dirty="0" err="1">
+                <a:solidFill>
+                  <a:srgbClr val="FFFFFF"/>
+                </a:solidFill>
+                <a:latin typeface="Calibri"/>
+              </a:rPr>
+              <a:t>viên</a:t>
+            </a:r>
+            <a:r>
+              <a:rPr sz="1400" b="0" i="0" dirty="0">
+                <a:solidFill>
+                  <a:srgbClr val="FFFFFF"/>
+                </a:solidFill>
+                <a:latin typeface="Calibri"/>
+              </a:rPr>
+              <a:t> </a:t>
+            </a:r>
+            <a:r>
+              <a:rPr sz="1400" b="0" i="0" dirty="0" err="1">
+                <a:solidFill>
+                  <a:srgbClr val="FFFFFF"/>
+                </a:solidFill>
+                <a:latin typeface="Calibri"/>
+              </a:rPr>
+              <a:t>thực</a:t>
+            </a:r>
+            <a:r>
+              <a:rPr sz="1400" b="0" i="0" dirty="0">
+                <a:solidFill>
+                  <a:srgbClr val="FFFFFF"/>
+                </a:solidFill>
+                <a:latin typeface="Calibri"/>
+              </a:rPr>
+              <a:t> </a:t>
+            </a:r>
+            <a:r>
+              <a:rPr sz="1400" b="0" i="0" dirty="0" err="1">
+                <a:solidFill>
+                  <a:srgbClr val="FFFFFF"/>
+                </a:solidFill>
+                <a:latin typeface="Calibri"/>
+              </a:rPr>
+              <a:t>hiện</a:t>
+            </a:r>
+            <a:r>
+              <a:rPr sz="1400" b="0" i="0" dirty="0">
+                <a:solidFill>
+                  <a:srgbClr val="FFFFFF"/>
+                </a:solidFill>
+                <a:latin typeface="Calibri"/>
+              </a:rPr>
+              <a:t>:  </a:t>
+            </a:r>
+            <a:r>
+              <a:rPr sz="1400" b="0" i="0" dirty="0" err="1">
+                <a:solidFill>
+                  <a:srgbClr val="FFFFFF"/>
+                </a:solidFill>
+                <a:latin typeface="Calibri"/>
+              </a:rPr>
+              <a:t>Đỗ</a:t>
+            </a:r>
+            <a:r>
+              <a:rPr sz="1400" b="0" i="0" dirty="0">
+                <a:solidFill>
+                  <a:srgbClr val="FFFFFF"/>
+                </a:solidFill>
+                <a:latin typeface="Calibri"/>
+              </a:rPr>
+              <a:t> Tuấn Minh — MSSV 20225741</a:t>
+            </a:r>
+          </a:p>
           <a:p>
             <a:pPr algn="ctr">
               <a:spcBef>
@@ -5042,14 +5136,92 @@
               <a:buNone/>
             </a:pPr>
             <a:r>
-              <a:rPr sz="1400" b="0" i="0">
+              <a:rPr sz="1400" b="0" i="0" dirty="0" err="1">
                 <a:solidFill>
                   <a:srgbClr val="FFFFFF"/>
                 </a:solidFill>
                 <a:latin typeface="Calibri"/>
               </a:rPr>
-              <a:t>Sinh viên thực hiện:  Đỗ Tuấn Minh — MSSV 20225741</a:t>
-            </a:r>
+              <a:t>Lớp</a:t>
+            </a:r>
+            <a:r>
+              <a:rPr sz="1400" b="0" i="0" dirty="0">
+                <a:solidFill>
+                  <a:srgbClr val="FFFFFF"/>
+                </a:solidFill>
+                <a:latin typeface="Calibri"/>
+              </a:rPr>
+              <a:t> Việt Nhật 07  ·  Trường Công </a:t>
+            </a:r>
+            <a:r>
+              <a:rPr sz="1400" b="0" i="0" dirty="0" err="1">
+                <a:solidFill>
+                  <a:srgbClr val="FFFFFF"/>
+                </a:solidFill>
+                <a:latin typeface="Calibri"/>
+              </a:rPr>
+              <a:t>nghệ</a:t>
+            </a:r>
+            <a:r>
+              <a:rPr sz="1400" b="0" i="0" dirty="0">
+                <a:solidFill>
+                  <a:srgbClr val="FFFFFF"/>
+                </a:solidFill>
+                <a:latin typeface="Calibri"/>
+              </a:rPr>
+              <a:t> Thông tin </a:t>
+            </a:r>
+            <a:r>
+              <a:rPr sz="1400" b="0" i="0" dirty="0" err="1">
+                <a:solidFill>
+                  <a:srgbClr val="FFFFFF"/>
+                </a:solidFill>
+                <a:latin typeface="Calibri"/>
+              </a:rPr>
+              <a:t>và</a:t>
+            </a:r>
+            <a:r>
+              <a:rPr sz="1400" b="0" i="0" dirty="0">
+                <a:solidFill>
+                  <a:srgbClr val="FFFFFF"/>
+                </a:solidFill>
+                <a:latin typeface="Calibri"/>
+              </a:rPr>
+              <a:t> </a:t>
+            </a:r>
+            <a:r>
+              <a:rPr sz="1400" b="0" i="0" dirty="0" err="1">
+                <a:solidFill>
+                  <a:srgbClr val="FFFFFF"/>
+                </a:solidFill>
+                <a:latin typeface="Calibri"/>
+              </a:rPr>
+              <a:t>Truyền</a:t>
+            </a:r>
+            <a:r>
+              <a:rPr sz="1400" b="0" i="0" dirty="0">
+                <a:solidFill>
+                  <a:srgbClr val="FFFFFF"/>
+                </a:solidFill>
+                <a:latin typeface="Calibri"/>
+              </a:rPr>
+              <a:t> </a:t>
+            </a:r>
+            <a:r>
+              <a:rPr sz="1400" b="0" i="0" dirty="0" err="1">
+                <a:solidFill>
+                  <a:srgbClr val="FFFFFF"/>
+                </a:solidFill>
+                <a:latin typeface="Calibri"/>
+              </a:rPr>
+              <a:t>thông</a:t>
+            </a:r>
+            <a:endParaRPr sz="1400" b="0" i="0" dirty="0">
+              <a:solidFill>
+                <a:srgbClr val="FFFFFF"/>
+              </a:solidFill>
+              <a:latin typeface="Calibri"/>
+            </a:endParaRPr>
           </a:p>
           <a:p>
             <a:pPr algn="ctr">
@@ -5062,13 +5234,76 @@
               <a:buNone/>
             </a:pPr>
             <a:r>
-              <a:rPr sz="1400" b="0" i="0">
+              <a:rPr sz="1400" b="0" i="0" dirty="0" err="1">
                 <a:solidFill>
                   <a:srgbClr val="FFFFFF"/>
                 </a:solidFill>
                 <a:latin typeface="Calibri"/>
               </a:rPr>
-              <a:t>Lớp Việt Nhật 07  ·  Trường Công nghệ Thông tin và Truyền thông</a:t>
+              <a:t>Giảng</a:t>
+            </a:r>
+            <a:r>
+              <a:rPr sz="1400" b="0" i="0" dirty="0">
+                <a:solidFill>
+                  <a:srgbClr val="FFFFFF"/>
+                </a:solidFill>
+                <a:latin typeface="Calibri"/>
+              </a:rPr>
+              <a:t> </a:t>
+            </a:r>
+            <a:r>
+              <a:rPr sz="1400" b="0" i="0" dirty="0" err="1">
+                <a:solidFill>
+                  <a:srgbClr val="FFFFFF"/>
+                </a:solidFill>
+                <a:latin typeface="Calibri"/>
+              </a:rPr>
+              <a:t>viên</a:t>
+            </a:r>
+            <a:r>
+              <a:rPr sz="1400" b="0" i="0" dirty="0">
+                <a:solidFill>
+                  <a:srgbClr val="FFFFFF"/>
+                </a:solidFill>
+                <a:latin typeface="Calibri"/>
+              </a:rPr>
+              <a:t> </a:t>
+            </a:r>
+            <a:r>
+              <a:rPr sz="1400" b="0" i="0" dirty="0" err="1">
+                <a:solidFill>
+                  <a:srgbClr val="FFFFFF"/>
+                </a:solidFill>
+                <a:latin typeface="Calibri"/>
+              </a:rPr>
+              <a:t>hướng</a:t>
+            </a:r>
+            <a:r>
+              <a:rPr sz="1400" b="0" i="0" dirty="0">
+                <a:solidFill>
+                  <a:srgbClr val="FFFFFF"/>
+                </a:solidFill>
+                <a:latin typeface="Calibri"/>
+              </a:rPr>
+              <a:t> </a:t>
+            </a:r>
+            <a:r>
+              <a:rPr sz="1400" b="0" i="0" dirty="0" err="1">
+                <a:solidFill>
+                  <a:srgbClr val="FFFFFF"/>
+                </a:solidFill>
+                <a:latin typeface="Calibri"/>
+              </a:rPr>
+              <a:t>dẫn</a:t>
+            </a:r>
+            <a:r>
+              <a:rPr sz="1400" b="0" i="0" dirty="0">
+                <a:solidFill>
+                  <a:srgbClr val="FFFFFF"/>
+                </a:solidFill>
+                <a:latin typeface="Calibri"/>
+              </a:rPr>
+              <a:t>:  PGS.TS. Nguyễn Linh Giang</a:t>
             </a:r>
           </a:p>
           <a:p>
@@ -5082,34 +5317,65 @@
               <a:buNone/>
             </a:pPr>
             <a:r>
-              <a:rPr sz="1400" b="0" i="0">
-                <a:solidFill>
-                  <a:srgbClr val="FFFFFF"/>
-                </a:solidFill>
-                <a:latin typeface="Calibri"/>
-              </a:rPr>
-              <a:t>Giảng viên hướng dẫn:  PGS.TS. Nguyễn Linh Giang</a:t>
-            </a:r>
-          </a:p>
-          <a:p>
-            <a:pPr algn="ctr">
-              <a:spcBef>
-                <a:spcPts val="200"/>
-              </a:spcBef>
-              <a:spcAft>
-                <a:spcPts val="300"/>
-              </a:spcAft>
-              <a:buNone/>
-            </a:pPr>
-            <a:r>
-              <a:rPr sz="1200" b="0" i="0">
+              <a:rPr sz="1200" b="0" i="0" dirty="0">
                 <a:solidFill>
                   <a:srgbClr val="C9D4E6"/>
                 </a:solidFill>
                 <a:latin typeface="Calibri"/>
               </a:rPr>
-              <a:t>Hà Nội, [tháng] / [năm]</a:t>
-            </a:r>
+              <a:t>Hà </a:t>
+            </a:r>
+            <a:r>
+              <a:rPr sz="1200" b="0" i="0" dirty="0" err="1">
+                <a:solidFill>
+                  <a:srgbClr val="C9D4E6"/>
+                </a:solidFill>
+                <a:latin typeface="Calibri"/>
+              </a:rPr>
+              <a:t>Nội</a:t>
+            </a:r>
+            <a:r>
+              <a:rPr sz="1200" b="0" i="0" dirty="0">
+                <a:solidFill>
+                  <a:srgbClr val="C9D4E6"/>
+                </a:solidFill>
+                <a:latin typeface="Calibri"/>
+              </a:rPr>
+              <a:t>, </a:t>
+            </a:r>
+            <a:r>
+              <a:rPr lang="en-US" sz="1200" b="0" i="0" dirty="0">
+                <a:solidFill>
+                  <a:srgbClr val="C9D4E6"/>
+                </a:solidFill>
+                <a:latin typeface="Calibri"/>
+              </a:rPr>
+              <a:t>7</a:t>
+            </a:r>
+            <a:r>
+              <a:rPr sz="1200" b="0" i="0" dirty="0">
+                <a:solidFill>
+                  <a:srgbClr val="C9D4E6"/>
+                </a:solidFill>
+                <a:latin typeface="Calibri"/>
+              </a:rPr>
+              <a:t>/ </a:t>
+            </a:r>
+            <a:r>
+              <a:rPr lang="en-US" sz="1200" b="0" i="0" dirty="0">
+                <a:solidFill>
+                  <a:srgbClr val="C9D4E6"/>
+                </a:solidFill>
+                <a:latin typeface="Calibri"/>
+              </a:rPr>
+              <a:t>2026</a:t>
+            </a:r>
+            <a:endParaRPr sz="1200" b="0" i="0" dirty="0">
+              <a:solidFill>
+                <a:srgbClr val="C9D4E6"/>
+              </a:solidFill>
+              <a:latin typeface="Calibri"/>
+            </a:endParaRPr>
           </a:p>
         </p:txBody>
       </p:sp>
@@ -5122,7 +5388,7 @@
 </file>
 
 <file path=ppt/slides/slide10.xml><?xml version="1.0" encoding="utf-8"?>
-<p:sld xmlns:a="http://schemas.openxmlformats.org/drawingml/2006/main" xmlns:p="http://schemas.openxmlformats.org/presentationml/2006/main" xmlns:r="http://schemas.openxmlformats.org/officeDocument/2006/relationships">
+<p:sld xmlns:a="http://schemas.openxmlformats.org/drawingml/2006/main" xmlns:r="http://schemas.openxmlformats.org/officeDocument/2006/relationships" xmlns:p="http://schemas.openxmlformats.org/presentationml/2006/main">
   <p:cSld>
     <p:spTree>
       <p:nvGrpSpPr>
@@ -5130,7 +5396,14 @@
         <p:cNvGrpSpPr/>
         <p:nvPr/>
       </p:nvGrpSpPr>
-      <p:grpSpPr/>
+      <p:grpSpPr>
+        <a:xfrm>
+          <a:off x="0" y="0"/>
+          <a:ext cx="0" cy="0"/>
+          <a:chOff x="0" y="0"/>
+          <a:chExt cx="0" cy="0"/>
+        </a:xfrm>
+      </p:grpSpPr>
       <p:sp>
         <p:nvSpPr>
           <p:cNvPr id="2" name="Title 1"/>
@@ -5199,7 +5472,7 @@
           </a:fontRef>
         </p:style>
         <p:txBody>
-          <a:bodyPr rtlCol="0" anchor="ctr" wrap="square" lIns="76200" rIns="76200" tIns="38100" bIns="38100"/>
+          <a:bodyPr wrap="square" lIns="76200" tIns="38100" rIns="76200" bIns="38100" rtlCol="0" anchor="ctr"/>
           <a:lstStyle/>
           <a:p>
             <a:pPr algn="ctr">
@@ -5240,7 +5513,7 @@
           <a:noFill/>
         </p:spPr>
         <p:txBody>
-          <a:bodyPr wrap="square" lIns="50800" rIns="50800" tIns="25400" bIns="25400">
+          <a:bodyPr wrap="square" lIns="50800" tIns="25400" rIns="50800" bIns="25400">
             <a:spAutoFit/>
           </a:bodyPr>
           <a:lstStyle/>
@@ -5327,7 +5600,7 @@
           </a:fontRef>
         </p:style>
         <p:txBody>
-          <a:bodyPr rtlCol="0" anchor="ctr" wrap="square" lIns="76200" rIns="76200" tIns="38100" bIns="38100"/>
+          <a:bodyPr wrap="square" lIns="76200" tIns="38100" rIns="76200" bIns="38100" rtlCol="0" anchor="ctr"/>
           <a:lstStyle/>
           <a:p>
             <a:pPr algn="l">
@@ -5412,7 +5685,7 @@
           </a:fontRef>
         </p:style>
         <p:txBody>
-          <a:bodyPr rtlCol="0" anchor="ctr" wrap="square" lIns="76200" rIns="76200" tIns="38100" bIns="38100"/>
+          <a:bodyPr wrap="square" lIns="76200" tIns="38100" rIns="76200" bIns="38100" rtlCol="0" anchor="ctr"/>
           <a:lstStyle/>
           <a:p>
             <a:pPr algn="l">
@@ -5524,7 +5797,7 @@
           </a:fontRef>
         </p:style>
         <p:txBody>
-          <a:bodyPr rtlCol="0" anchor="ctr" wrap="square" lIns="76200" rIns="76200" tIns="38100" bIns="38100"/>
+          <a:bodyPr wrap="square" lIns="76200" tIns="38100" rIns="76200" bIns="38100" rtlCol="0" anchor="ctr"/>
           <a:lstStyle/>
           <a:p>
             <a:pPr algn="ctr">
@@ -5557,7 +5830,7 @@
 </file>
 
 <file path=ppt/slides/slide11.xml><?xml version="1.0" encoding="utf-8"?>
-<p:sld xmlns:a="http://schemas.openxmlformats.org/drawingml/2006/main" xmlns:p="http://schemas.openxmlformats.org/presentationml/2006/main" xmlns:r="http://schemas.openxmlformats.org/officeDocument/2006/relationships">
+<p:sld xmlns:a="http://schemas.openxmlformats.org/drawingml/2006/main" xmlns:r="http://schemas.openxmlformats.org/officeDocument/2006/relationships" xmlns:p="http://schemas.openxmlformats.org/presentationml/2006/main">
   <p:cSld>
     <p:spTree>
       <p:nvGrpSpPr>
@@ -5565,7 +5838,14 @@
         <p:cNvGrpSpPr/>
         <p:nvPr/>
       </p:nvGrpSpPr>
-      <p:grpSpPr/>
+      <p:grpSpPr>
+        <a:xfrm>
+          <a:off x="0" y="0"/>
+          <a:ext cx="0" cy="0"/>
+          <a:chOff x="0" y="0"/>
+          <a:chExt cx="0" cy="0"/>
+        </a:xfrm>
+      </p:grpSpPr>
       <p:sp>
         <p:nvSpPr>
           <p:cNvPr id="2" name="Title 1"/>
@@ -5634,7 +5914,7 @@
           </a:fontRef>
         </p:style>
         <p:txBody>
-          <a:bodyPr rtlCol="0" anchor="ctr" wrap="square" lIns="76200" rIns="76200" tIns="38100" bIns="38100"/>
+          <a:bodyPr wrap="square" lIns="76200" tIns="38100" rIns="76200" bIns="38100" rtlCol="0" anchor="ctr"/>
           <a:lstStyle/>
           <a:p>
             <a:pPr algn="ctr">
@@ -5699,7 +5979,7 @@
           </a:fontRef>
         </p:style>
         <p:txBody>
-          <a:bodyPr rtlCol="0" anchor="ctr" wrap="square" lIns="76200" rIns="76200" tIns="38100" bIns="38100"/>
+          <a:bodyPr wrap="square" lIns="76200" tIns="38100" rIns="76200" bIns="38100" rtlCol="0" anchor="ctr"/>
           <a:lstStyle/>
           <a:p>
             <a:pPr algn="ctr">
@@ -5804,6 +6084,7 @@
           <a:lstStyle/>
           <a:p>
             <a:pPr algn="ctr"/>
+            <a:endParaRPr/>
           </a:p>
         </p:txBody>
       </p:sp>
@@ -5848,7 +6129,7 @@
           </a:fontRef>
         </p:style>
         <p:txBody>
-          <a:bodyPr rtlCol="0" anchor="ctr" wrap="square" lIns="76200" rIns="76200" tIns="38100" bIns="38100"/>
+          <a:bodyPr wrap="square" lIns="76200" tIns="38100" rIns="76200" bIns="38100" rtlCol="0" anchor="ctr"/>
           <a:lstStyle/>
           <a:p>
             <a:pPr algn="ctr">
@@ -5953,6 +6234,7 @@
           <a:lstStyle/>
           <a:p>
             <a:pPr algn="ctr"/>
+            <a:endParaRPr/>
           </a:p>
         </p:txBody>
       </p:sp>
@@ -5997,7 +6279,7 @@
           </a:fontRef>
         </p:style>
         <p:txBody>
-          <a:bodyPr rtlCol="0" anchor="ctr" wrap="square" lIns="76200" rIns="76200" tIns="38100" bIns="38100"/>
+          <a:bodyPr wrap="square" lIns="76200" tIns="38100" rIns="76200" bIns="38100" rtlCol="0" anchor="ctr"/>
           <a:lstStyle/>
           <a:p>
             <a:pPr algn="ctr">
@@ -6078,7 +6360,7 @@
           <a:noFill/>
         </p:spPr>
         <p:txBody>
-          <a:bodyPr wrap="square" lIns="50800" rIns="50800" tIns="25400" bIns="25400">
+          <a:bodyPr wrap="square" lIns="50800" tIns="25400" rIns="50800" bIns="25400">
             <a:spAutoFit/>
           </a:bodyPr>
           <a:lstStyle/>
@@ -6103,7 +6385,7 @@
             </a:r>
           </a:p>
           <a:p>
-            <a:pPr algn="l" indent="-137160" marL="137160">
+            <a:pPr marL="137160" indent="-137160" algn="l">
               <a:spcBef>
                 <a:spcPts val="200"/>
               </a:spcBef>
@@ -6124,7 +6406,7 @@
             </a:r>
           </a:p>
           <a:p>
-            <a:pPr algn="l" indent="-137160" marL="137160">
+            <a:pPr marL="137160" indent="-137160" algn="l">
               <a:spcBef>
                 <a:spcPts val="200"/>
               </a:spcBef>
@@ -6185,7 +6467,7 @@
           </a:fontRef>
         </p:style>
         <p:txBody>
-          <a:bodyPr rtlCol="0" anchor="ctr" wrap="square" lIns="76200" rIns="76200" tIns="38100" bIns="38100"/>
+          <a:bodyPr wrap="square" lIns="76200" tIns="38100" rIns="76200" bIns="38100" rtlCol="0" anchor="ctr"/>
           <a:lstStyle/>
           <a:p>
             <a:pPr algn="l">
@@ -6267,7 +6549,7 @@
 </file>
 
 <file path=ppt/slides/slide12.xml><?xml version="1.0" encoding="utf-8"?>
-<p:sld xmlns:a="http://schemas.openxmlformats.org/drawingml/2006/main" xmlns:p="http://schemas.openxmlformats.org/presentationml/2006/main" xmlns:r="http://schemas.openxmlformats.org/officeDocument/2006/relationships">
+<p:sld xmlns:a="http://schemas.openxmlformats.org/drawingml/2006/main" xmlns:r="http://schemas.openxmlformats.org/officeDocument/2006/relationships" xmlns:p="http://schemas.openxmlformats.org/presentationml/2006/main">
   <p:cSld>
     <p:spTree>
       <p:nvGrpSpPr>
@@ -6275,7 +6557,14 @@
         <p:cNvGrpSpPr/>
         <p:nvPr/>
       </p:nvGrpSpPr>
-      <p:grpSpPr/>
+      <p:grpSpPr>
+        <a:xfrm>
+          <a:off x="0" y="0"/>
+          <a:ext cx="0" cy="0"/>
+          <a:chOff x="0" y="0"/>
+          <a:chExt cx="0" cy="0"/>
+        </a:xfrm>
+      </p:grpSpPr>
       <p:sp>
         <p:nvSpPr>
           <p:cNvPr id="2" name="Title 1"/>
@@ -6344,7 +6633,7 @@
           </a:fontRef>
         </p:style>
         <p:txBody>
-          <a:bodyPr rtlCol="0" anchor="ctr" wrap="square" lIns="76200" rIns="76200" tIns="38100" bIns="38100"/>
+          <a:bodyPr wrap="square" lIns="76200" tIns="38100" rIns="76200" bIns="38100" rtlCol="0" anchor="ctr"/>
           <a:lstStyle/>
           <a:p>
             <a:pPr algn="ctr">
@@ -6407,7 +6696,7 @@
           </a:fontRef>
         </p:style>
         <p:txBody>
-          <a:bodyPr rtlCol="0" anchor="ctr" wrap="square" lIns="76200" rIns="76200" tIns="38100" bIns="38100"/>
+          <a:bodyPr wrap="square" lIns="76200" tIns="38100" rIns="76200" bIns="38100" rtlCol="0" anchor="ctr"/>
           <a:lstStyle/>
           <a:p>
             <a:pPr algn="ctr">
@@ -6492,6 +6781,7 @@
           <a:lstStyle/>
           <a:p>
             <a:pPr algn="ctr"/>
+            <a:endParaRPr/>
           </a:p>
         </p:txBody>
       </p:sp>
@@ -6534,7 +6824,7 @@
           </a:fontRef>
         </p:style>
         <p:txBody>
-          <a:bodyPr rtlCol="0" anchor="ctr" wrap="square" lIns="76200" rIns="76200" tIns="38100" bIns="38100"/>
+          <a:bodyPr wrap="square" lIns="76200" tIns="38100" rIns="76200" bIns="38100" rtlCol="0" anchor="ctr"/>
           <a:lstStyle/>
           <a:p>
             <a:pPr algn="ctr">
@@ -6619,6 +6909,7 @@
           <a:lstStyle/>
           <a:p>
             <a:pPr algn="ctr"/>
+            <a:endParaRPr/>
           </a:p>
         </p:txBody>
       </p:sp>
@@ -6661,7 +6952,7 @@
           </a:fontRef>
         </p:style>
         <p:txBody>
-          <a:bodyPr rtlCol="0" anchor="ctr" wrap="square" lIns="76200" rIns="76200" tIns="38100" bIns="38100"/>
+          <a:bodyPr wrap="square" lIns="76200" tIns="38100" rIns="76200" bIns="38100" rtlCol="0" anchor="ctr"/>
           <a:lstStyle/>
           <a:p>
             <a:pPr algn="ctr">
@@ -6744,7 +7035,7 @@
           </a:fontRef>
         </p:style>
         <p:txBody>
-          <a:bodyPr rtlCol="0" anchor="ctr" wrap="square" lIns="76200" rIns="76200" tIns="38100" bIns="38100"/>
+          <a:bodyPr wrap="square" lIns="76200" tIns="38100" rIns="76200" bIns="38100" rtlCol="0" anchor="ctr"/>
           <a:lstStyle/>
           <a:p>
             <a:pPr algn="ctr">
@@ -6829,7 +7120,7 @@
           </a:fontRef>
         </p:style>
         <p:txBody>
-          <a:bodyPr rtlCol="0" anchor="ctr" wrap="square" lIns="76200" rIns="76200" tIns="38100" bIns="38100"/>
+          <a:bodyPr wrap="square" lIns="76200" tIns="38100" rIns="76200" bIns="38100" rtlCol="0" anchor="ctr"/>
           <a:lstStyle/>
           <a:p>
             <a:pPr algn="l">
@@ -6914,7 +7205,7 @@
           </a:fontRef>
         </p:style>
         <p:txBody>
-          <a:bodyPr rtlCol="0" anchor="ctr" wrap="square" lIns="76200" rIns="76200" tIns="38100" bIns="38100"/>
+          <a:bodyPr wrap="square" lIns="76200" tIns="38100" rIns="76200" bIns="38100" rtlCol="0" anchor="ctr"/>
           <a:lstStyle/>
           <a:p>
             <a:pPr algn="l">
@@ -6987,7 +7278,7 @@
 </file>
 
 <file path=ppt/slides/slide13.xml><?xml version="1.0" encoding="utf-8"?>
-<p:sld xmlns:a="http://schemas.openxmlformats.org/drawingml/2006/main" xmlns:p="http://schemas.openxmlformats.org/presentationml/2006/main" xmlns:r="http://schemas.openxmlformats.org/officeDocument/2006/relationships">
+<p:sld xmlns:a="http://schemas.openxmlformats.org/drawingml/2006/main" xmlns:r="http://schemas.openxmlformats.org/officeDocument/2006/relationships" xmlns:p="http://schemas.openxmlformats.org/presentationml/2006/main">
   <p:cSld>
     <p:spTree>
       <p:nvGrpSpPr>
@@ -6995,7 +7286,14 @@
         <p:cNvGrpSpPr/>
         <p:nvPr/>
       </p:nvGrpSpPr>
-      <p:grpSpPr/>
+      <p:grpSpPr>
+        <a:xfrm>
+          <a:off x="0" y="0"/>
+          <a:ext cx="0" cy="0"/>
+          <a:chOff x="0" y="0"/>
+          <a:chExt cx="0" cy="0"/>
+        </a:xfrm>
+      </p:grpSpPr>
       <p:sp>
         <p:nvSpPr>
           <p:cNvPr id="2" name="Title 1"/>
@@ -7064,7 +7362,7 @@
           </a:fontRef>
         </p:style>
         <p:txBody>
-          <a:bodyPr rtlCol="0" anchor="ctr" wrap="square" lIns="76200" rIns="76200" tIns="38100" bIns="38100"/>
+          <a:bodyPr wrap="square" lIns="76200" tIns="38100" rIns="76200" bIns="38100" rtlCol="0" anchor="ctr"/>
           <a:lstStyle/>
           <a:p>
             <a:pPr algn="ctr">
@@ -7134,7 +7432,7 @@
           <a:noFill/>
         </p:spPr>
         <p:txBody>
-          <a:bodyPr wrap="square" lIns="50800" rIns="50800" tIns="25400" bIns="25400">
+          <a:bodyPr wrap="square" lIns="50800" tIns="25400" rIns="50800" bIns="25400">
             <a:spAutoFit/>
           </a:bodyPr>
           <a:lstStyle/>
@@ -7201,7 +7499,7 @@
           </a:fontRef>
         </p:style>
         <p:txBody>
-          <a:bodyPr rtlCol="0" anchor="ctr" wrap="square" lIns="76200" rIns="76200" tIns="38100" bIns="38100"/>
+          <a:bodyPr wrap="square" lIns="76200" tIns="38100" rIns="76200" bIns="38100" rtlCol="0" anchor="ctr"/>
           <a:lstStyle/>
           <a:p>
             <a:pPr algn="ctr">
@@ -7262,12 +7560,12 @@
           <a:noFill/>
         </p:spPr>
         <p:txBody>
-          <a:bodyPr wrap="square" lIns="50800" rIns="50800" tIns="25400" bIns="25400">
+          <a:bodyPr wrap="square" lIns="50800" tIns="25400" rIns="50800" bIns="25400">
             <a:spAutoFit/>
           </a:bodyPr>
           <a:lstStyle/>
           <a:p>
-            <a:pPr algn="l" indent="-137160" marL="137160">
+            <a:pPr marL="137160" indent="-137160" algn="l">
               <a:spcBef>
                 <a:spcPts val="200"/>
               </a:spcBef>
@@ -7288,7 +7586,7 @@
             </a:r>
           </a:p>
           <a:p>
-            <a:pPr algn="l" indent="-137160" marL="137160">
+            <a:pPr marL="137160" indent="-137160" algn="l">
               <a:spcBef>
                 <a:spcPts val="200"/>
               </a:spcBef>
@@ -7349,7 +7647,7 @@
           </a:fontRef>
         </p:style>
         <p:txBody>
-          <a:bodyPr rtlCol="0" anchor="ctr" wrap="square" lIns="76200" rIns="76200" tIns="38100" bIns="38100"/>
+          <a:bodyPr wrap="square" lIns="76200" tIns="38100" rIns="76200" bIns="38100" rtlCol="0" anchor="ctr"/>
           <a:lstStyle/>
           <a:p>
             <a:pPr algn="l">
@@ -7422,7 +7720,7 @@
 </file>
 
 <file path=ppt/slides/slide14.xml><?xml version="1.0" encoding="utf-8"?>
-<p:sld xmlns:a="http://schemas.openxmlformats.org/drawingml/2006/main" xmlns:p="http://schemas.openxmlformats.org/presentationml/2006/main" xmlns:r="http://schemas.openxmlformats.org/officeDocument/2006/relationships">
+<p:sld xmlns:a="http://schemas.openxmlformats.org/drawingml/2006/main" xmlns:r="http://schemas.openxmlformats.org/officeDocument/2006/relationships" xmlns:p="http://schemas.openxmlformats.org/presentationml/2006/main">
   <p:cSld>
     <p:spTree>
       <p:nvGrpSpPr>
@@ -7430,7 +7728,14 @@
         <p:cNvGrpSpPr/>
         <p:nvPr/>
       </p:nvGrpSpPr>
-      <p:grpSpPr/>
+      <p:grpSpPr>
+        <a:xfrm>
+          <a:off x="0" y="0"/>
+          <a:ext cx="0" cy="0"/>
+          <a:chOff x="0" y="0"/>
+          <a:chExt cx="0" cy="0"/>
+        </a:xfrm>
+      </p:grpSpPr>
       <p:sp>
         <p:nvSpPr>
           <p:cNvPr id="2" name="Title 1"/>
@@ -7479,9 +7784,27 @@
                 <a:tableStyleId>{5C22544A-7EE6-4342-B048-85BDC9FD1C3A}</a:tableStyleId>
               </a:tblPr>
               <a:tblGrid>
-                <a:gridCol w="2743200"/>
-                <a:gridCol w="2514600"/>
-                <a:gridCol w="2514600"/>
+                <a:gridCol w="2743200">
+                  <a:extLst>
+                    <a:ext uri="{9D8B030D-6E8A-4147-A177-3AD203B41FA5}">
+                      <a16:colId xmlns:a16="http://schemas.microsoft.com/office/drawing/2014/main" val="20000"/>
+                    </a:ext>
+                  </a:extLst>
+                </a:gridCol>
+                <a:gridCol w="2514600">
+                  <a:extLst>
+                    <a:ext uri="{9D8B030D-6E8A-4147-A177-3AD203B41FA5}">
+                      <a16:colId xmlns:a16="http://schemas.microsoft.com/office/drawing/2014/main" val="20001"/>
+                    </a:ext>
+                  </a:extLst>
+                </a:gridCol>
+                <a:gridCol w="2514600">
+                  <a:extLst>
+                    <a:ext uri="{9D8B030D-6E8A-4147-A177-3AD203B41FA5}">
+                      <a16:colId xmlns:a16="http://schemas.microsoft.com/office/drawing/2014/main" val="20002"/>
+                    </a:ext>
+                  </a:extLst>
+                </a:gridCol>
               </a:tblGrid>
               <a:tr h="464820">
                 <a:tc>
@@ -7553,6 +7876,11 @@
                     </a:solidFill>
                   </a:tcPr>
                 </a:tc>
+                <a:extLst>
+                  <a:ext uri="{0D108BD9-81ED-4DB2-BD59-A6C34878D82A}">
+                    <a16:rowId xmlns:a16="http://schemas.microsoft.com/office/drawing/2014/main" val="10000"/>
+                  </a:ext>
+                </a:extLst>
               </a:tr>
               <a:tr h="464820">
                 <a:tc>
@@ -7624,6 +7952,11 @@
                     </a:solidFill>
                   </a:tcPr>
                 </a:tc>
+                <a:extLst>
+                  <a:ext uri="{0D108BD9-81ED-4DB2-BD59-A6C34878D82A}">
+                    <a16:rowId xmlns:a16="http://schemas.microsoft.com/office/drawing/2014/main" val="10001"/>
+                  </a:ext>
+                </a:extLst>
               </a:tr>
               <a:tr h="464820">
                 <a:tc>
@@ -7695,6 +8028,11 @@
                     </a:solidFill>
                   </a:tcPr>
                 </a:tc>
+                <a:extLst>
+                  <a:ext uri="{0D108BD9-81ED-4DB2-BD59-A6C34878D82A}">
+                    <a16:rowId xmlns:a16="http://schemas.microsoft.com/office/drawing/2014/main" val="10002"/>
+                  </a:ext>
+                </a:extLst>
               </a:tr>
               <a:tr h="464820">
                 <a:tc>
@@ -7766,6 +8104,11 @@
                     </a:solidFill>
                   </a:tcPr>
                 </a:tc>
+                <a:extLst>
+                  <a:ext uri="{0D108BD9-81ED-4DB2-BD59-A6C34878D82A}">
+                    <a16:rowId xmlns:a16="http://schemas.microsoft.com/office/drawing/2014/main" val="10003"/>
+                  </a:ext>
+                </a:extLst>
               </a:tr>
               <a:tr h="464820">
                 <a:tc>
@@ -7837,6 +8180,11 @@
                     </a:solidFill>
                   </a:tcPr>
                 </a:tc>
+                <a:extLst>
+                  <a:ext uri="{0D108BD9-81ED-4DB2-BD59-A6C34878D82A}">
+                    <a16:rowId xmlns:a16="http://schemas.microsoft.com/office/drawing/2014/main" val="10004"/>
+                  </a:ext>
+                </a:extLst>
               </a:tr>
               <a:tr h="464820">
                 <a:tc>
@@ -7908,6 +8256,11 @@
                     </a:solidFill>
                   </a:tcPr>
                 </a:tc>
+                <a:extLst>
+                  <a:ext uri="{0D108BD9-81ED-4DB2-BD59-A6C34878D82A}">
+                    <a16:rowId xmlns:a16="http://schemas.microsoft.com/office/drawing/2014/main" val="10005"/>
+                  </a:ext>
+                </a:extLst>
               </a:tr>
             </a:tbl>
           </a:graphicData>
@@ -7952,7 +8305,7 @@
           </a:fontRef>
         </p:style>
         <p:txBody>
-          <a:bodyPr rtlCol="0" anchor="ctr" wrap="square" lIns="76200" rIns="76200" tIns="38100" bIns="38100"/>
+          <a:bodyPr wrap="square" lIns="76200" tIns="38100" rIns="76200" bIns="38100" rtlCol="0" anchor="ctr"/>
           <a:lstStyle/>
           <a:p>
             <a:pPr algn="ctr">
@@ -7985,7 +8338,7 @@
 </file>
 
 <file path=ppt/slides/slide15.xml><?xml version="1.0" encoding="utf-8"?>
-<p:sld xmlns:a="http://schemas.openxmlformats.org/drawingml/2006/main" xmlns:p="http://schemas.openxmlformats.org/presentationml/2006/main" xmlns:r="http://schemas.openxmlformats.org/officeDocument/2006/relationships">
+<p:sld xmlns:a="http://schemas.openxmlformats.org/drawingml/2006/main" xmlns:r="http://schemas.openxmlformats.org/officeDocument/2006/relationships" xmlns:p="http://schemas.openxmlformats.org/presentationml/2006/main">
   <p:cSld>
     <p:spTree>
       <p:nvGrpSpPr>
@@ -7993,7 +8346,14 @@
         <p:cNvGrpSpPr/>
         <p:nvPr/>
       </p:nvGrpSpPr>
-      <p:grpSpPr/>
+      <p:grpSpPr>
+        <a:xfrm>
+          <a:off x="0" y="0"/>
+          <a:ext cx="0" cy="0"/>
+          <a:chOff x="0" y="0"/>
+          <a:chExt cx="0" cy="0"/>
+        </a:xfrm>
+      </p:grpSpPr>
       <p:sp>
         <p:nvSpPr>
           <p:cNvPr id="2" name="Title 1"/>
@@ -8025,86 +8385,13 @@
       </p:sp>
       <p:sp>
         <p:nvSpPr>
-          <p:cNvPr id="3" name="Rounded Rectangle 2"/>
-          <p:cNvSpPr/>
-          <p:nvPr/>
-        </p:nvSpPr>
-        <p:spPr>
-          <a:xfrm>
-            <a:off x="640080" y="1463040"/>
-            <a:ext cx="7863840" cy="2788920"/>
-          </a:xfrm>
-          <a:prstGeom prst="roundRect">
-            <a:avLst>
-              <a:gd name="adj" fmla="val 8000"/>
-            </a:avLst>
-          </a:prstGeom>
-          <a:solidFill>
-            <a:srgbClr val="F2F4F8"/>
-          </a:solidFill>
-          <a:ln w="12700">
-            <a:solidFill>
-              <a:srgbClr val="DDE4F0"/>
-            </a:solidFill>
-          </a:ln>
-          <a:effectLst/>
-        </p:spPr>
-        <p:style>
-          <a:lnRef idx="1">
-            <a:schemeClr val="accent1"/>
-          </a:lnRef>
-          <a:fillRef idx="3">
-            <a:schemeClr val="accent1"/>
-          </a:fillRef>
-          <a:effectRef idx="2">
-            <a:schemeClr val="accent1"/>
-          </a:effectRef>
-          <a:fontRef idx="minor">
-            <a:schemeClr val="lt1"/>
-          </a:fontRef>
-        </p:style>
-        <p:txBody>
-          <a:bodyPr rtlCol="0" anchor="ctr" wrap="square"/>
-          <a:lstStyle/>
-          <a:p>
-            <a:pPr algn="ctr">
-              <a:buNone/>
-            </a:pPr>
-            <a:r>
-              <a:rPr sz="1400" i="1">
-                <a:solidFill>
-                  <a:srgbClr val="606060"/>
-                </a:solidFill>
-                <a:latin typeface="Calibri"/>
-              </a:rPr>
-              <a:t>[ Ảnh chụp màn hình dashboard.html đang phát hiện realtime — kịch bản "dos" ]</a:t>
-            </a:r>
-          </a:p>
-          <a:p>
-            <a:pPr algn="ctr">
-              <a:buNone/>
-            </a:pPr>
-            <a:r>
-              <a:rPr sz="1000">
-                <a:solidFill>
-                  <a:srgbClr val="606060"/>
-                </a:solidFill>
-                <a:latin typeface="Calibri"/>
-              </a:rPr>
-              <a:t>Nguồn: Final/05_Replay_Detection/dashboard.html</a:t>
-            </a:r>
-          </a:p>
-        </p:txBody>
-      </p:sp>
-      <p:sp>
-        <p:nvSpPr>
           <p:cNvPr id="4" name="Rounded Rectangle 3"/>
           <p:cNvSpPr/>
           <p:nvPr/>
         </p:nvSpPr>
         <p:spPr>
           <a:xfrm>
-            <a:off x="640080" y="4389120"/>
+            <a:off x="705394" y="5010912"/>
             <a:ext cx="7863840" cy="621792"/>
           </a:xfrm>
           <a:prstGeom prst="roundRect">
@@ -8135,7 +8422,7 @@
           </a:fontRef>
         </p:style>
         <p:txBody>
-          <a:bodyPr rtlCol="0" anchor="ctr" wrap="square" lIns="76200" rIns="76200" tIns="38100" bIns="38100"/>
+          <a:bodyPr wrap="square" lIns="76200" tIns="38100" rIns="76200" bIns="38100" rtlCol="0" anchor="ctr"/>
           <a:lstStyle/>
           <a:p>
             <a:pPr algn="ctr">
@@ -8148,13 +8435,139 @@
               <a:buNone/>
             </a:pPr>
             <a:r>
-              <a:rPr sz="1200" b="1">
+              <a:rPr sz="1200" b="1" dirty="0">
                 <a:solidFill>
                   <a:srgbClr val="FFFFFF"/>
                 </a:solidFill>
                 <a:latin typeface="Calibri"/>
               </a:rPr>
-              <a:t>REPLAY ≠ LIVE: phát lại corpus flow đã thu (CSV) → suy luận realtime qua WebSocket.</a:t>
+              <a:t>REPLAY ≠ LIVE: </a:t>
+            </a:r>
+            <a:r>
+              <a:rPr sz="1200" b="1" dirty="0" err="1">
+                <a:solidFill>
+                  <a:srgbClr val="FFFFFF"/>
+                </a:solidFill>
+                <a:latin typeface="Calibri"/>
+              </a:rPr>
+              <a:t>phát</a:t>
+            </a:r>
+            <a:r>
+              <a:rPr sz="1200" b="1" dirty="0">
+                <a:solidFill>
+                  <a:srgbClr val="FFFFFF"/>
+                </a:solidFill>
+                <a:latin typeface="Calibri"/>
+              </a:rPr>
+              <a:t> </a:t>
+            </a:r>
+            <a:r>
+              <a:rPr sz="1200" b="1" dirty="0" err="1">
+                <a:solidFill>
+                  <a:srgbClr val="FFFFFF"/>
+                </a:solidFill>
+                <a:latin typeface="Calibri"/>
+              </a:rPr>
+              <a:t>lại</a:t>
+            </a:r>
+            <a:r>
+              <a:rPr sz="1200" b="1" dirty="0">
+                <a:solidFill>
+                  <a:srgbClr val="FFFFFF"/>
+                </a:solidFill>
+                <a:latin typeface="Calibri"/>
+              </a:rPr>
+              <a:t> corpus flow </a:t>
+            </a:r>
+            <a:r>
+              <a:rPr sz="1200" b="1" dirty="0" err="1">
+                <a:solidFill>
+                  <a:srgbClr val="FFFFFF"/>
+                </a:solidFill>
+                <a:latin typeface="Calibri"/>
+              </a:rPr>
+              <a:t>đã</a:t>
+            </a:r>
+            <a:r>
+              <a:rPr sz="1200" b="1" dirty="0">
+                <a:solidFill>
+                  <a:srgbClr val="FFFFFF"/>
+                </a:solidFill>
+                <a:latin typeface="Calibri"/>
+              </a:rPr>
+              <a:t> </a:t>
+            </a:r>
+            <a:r>
+              <a:rPr sz="1200" b="1" dirty="0" err="1">
+                <a:solidFill>
+                  <a:srgbClr val="FFFFFF"/>
+                </a:solidFill>
+                <a:latin typeface="Calibri"/>
+              </a:rPr>
+              <a:t>thu</a:t>
+            </a:r>
+            <a:r>
+              <a:rPr sz="1200" b="1" dirty="0">
+                <a:solidFill>
+                  <a:srgbClr val="FFFFFF"/>
+                </a:solidFill>
+                <a:latin typeface="Calibri"/>
+              </a:rPr>
+              <a:t> (CSV) → </a:t>
+            </a:r>
+            <a:r>
+              <a:rPr sz="1200" b="1" dirty="0" err="1">
+                <a:solidFill>
+                  <a:srgbClr val="FFFFFF"/>
+                </a:solidFill>
+                <a:latin typeface="Calibri"/>
+              </a:rPr>
+              <a:t>suy</a:t>
+            </a:r>
+            <a:r>
+              <a:rPr sz="1200" b="1" dirty="0">
+                <a:solidFill>
+                  <a:srgbClr val="FFFFFF"/>
+                </a:solidFill>
+                <a:latin typeface="Calibri"/>
+              </a:rPr>
+              <a:t> </a:t>
+            </a:r>
+            <a:r>
+              <a:rPr sz="1200" b="1" dirty="0" err="1">
+                <a:solidFill>
+                  <a:srgbClr val="FFFFFF"/>
+                </a:solidFill>
+                <a:latin typeface="Calibri"/>
+              </a:rPr>
+              <a:t>luận</a:t>
+            </a:r>
+            <a:r>
+              <a:rPr sz="1200" b="1" dirty="0">
+                <a:solidFill>
+                  <a:srgbClr val="FFFFFF"/>
+                </a:solidFill>
+                <a:latin typeface="Calibri"/>
+              </a:rPr>
+              <a:t> </a:t>
+            </a:r>
+            <a:r>
+              <a:rPr sz="1200" b="1" dirty="0" err="1">
+                <a:solidFill>
+                  <a:srgbClr val="FFFFFF"/>
+                </a:solidFill>
+                <a:latin typeface="Calibri"/>
+              </a:rPr>
+              <a:t>realtime</a:t>
+            </a:r>
+            <a:r>
+              <a:rPr sz="1200" b="1" dirty="0">
+                <a:solidFill>
+                  <a:srgbClr val="FFFFFF"/>
+                </a:solidFill>
+                <a:latin typeface="Calibri"/>
+              </a:rPr>
+              <a:t> qua WebSocket.</a:t>
             </a:r>
           </a:p>
           <a:p>
@@ -8168,17 +8581,290 @@
               <a:buNone/>
             </a:pPr>
             <a:r>
-              <a:rPr sz="1150" b="0">
+              <a:rPr sz="1150" b="0" dirty="0" err="1">
                 <a:solidFill>
                   <a:srgbClr val="FFD966"/>
                 </a:solidFill>
                 <a:latin typeface="Calibri"/>
               </a:rPr>
-              <a:t>Bắt gói trực tiếp (live capture) = hướng phát triển, chưa nằm trong kết quả báo cáo.</a:t>
-            </a:r>
-          </a:p>
-        </p:txBody>
-      </p:sp>
+              <a:t>Bắt</a:t>
+            </a:r>
+            <a:r>
+              <a:rPr sz="1150" b="0" dirty="0">
+                <a:solidFill>
+                  <a:srgbClr val="FFD966"/>
+                </a:solidFill>
+                <a:latin typeface="Calibri"/>
+              </a:rPr>
+              <a:t> </a:t>
+            </a:r>
+            <a:r>
+              <a:rPr sz="1150" b="0" dirty="0" err="1">
+                <a:solidFill>
+                  <a:srgbClr val="FFD966"/>
+                </a:solidFill>
+                <a:latin typeface="Calibri"/>
+              </a:rPr>
+              <a:t>gói</a:t>
+            </a:r>
+            <a:r>
+              <a:rPr sz="1150" b="0" dirty="0">
+                <a:solidFill>
+                  <a:srgbClr val="FFD966"/>
+                </a:solidFill>
+                <a:latin typeface="Calibri"/>
+              </a:rPr>
+              <a:t> </a:t>
+            </a:r>
+            <a:r>
+              <a:rPr sz="1150" b="0" dirty="0" err="1">
+                <a:solidFill>
+                  <a:srgbClr val="FFD966"/>
+                </a:solidFill>
+                <a:latin typeface="Calibri"/>
+              </a:rPr>
+              <a:t>trực</a:t>
+            </a:r>
+            <a:r>
+              <a:rPr sz="1150" b="0" dirty="0">
+                <a:solidFill>
+                  <a:srgbClr val="FFD966"/>
+                </a:solidFill>
+                <a:latin typeface="Calibri"/>
+              </a:rPr>
+              <a:t> </a:t>
+            </a:r>
+            <a:r>
+              <a:rPr sz="1150" b="0" dirty="0" err="1">
+                <a:solidFill>
+                  <a:srgbClr val="FFD966"/>
+                </a:solidFill>
+                <a:latin typeface="Calibri"/>
+              </a:rPr>
+              <a:t>tiếp</a:t>
+            </a:r>
+            <a:r>
+              <a:rPr sz="1150" b="0" dirty="0">
+                <a:solidFill>
+                  <a:srgbClr val="FFD966"/>
+                </a:solidFill>
+                <a:latin typeface="Calibri"/>
+              </a:rPr>
+              <a:t> (live capture) = </a:t>
+            </a:r>
+            <a:r>
+              <a:rPr sz="1150" b="0" dirty="0" err="1">
+                <a:solidFill>
+                  <a:srgbClr val="FFD966"/>
+                </a:solidFill>
+                <a:latin typeface="Calibri"/>
+              </a:rPr>
+              <a:t>hướng</a:t>
+            </a:r>
+            <a:r>
+              <a:rPr sz="1150" b="0" dirty="0">
+                <a:solidFill>
+                  <a:srgbClr val="FFD966"/>
+                </a:solidFill>
+                <a:latin typeface="Calibri"/>
+              </a:rPr>
+              <a:t> </a:t>
+            </a:r>
+            <a:r>
+              <a:rPr sz="1150" b="0" dirty="0" err="1">
+                <a:solidFill>
+                  <a:srgbClr val="FFD966"/>
+                </a:solidFill>
+                <a:latin typeface="Calibri"/>
+              </a:rPr>
+              <a:t>phát</a:t>
+            </a:r>
+            <a:r>
+              <a:rPr sz="1150" b="0" dirty="0">
+                <a:solidFill>
+                  <a:srgbClr val="FFD966"/>
+                </a:solidFill>
+                <a:latin typeface="Calibri"/>
+              </a:rPr>
+              <a:t> </a:t>
+            </a:r>
+            <a:r>
+              <a:rPr sz="1150" b="0" dirty="0" err="1">
+                <a:solidFill>
+                  <a:srgbClr val="FFD966"/>
+                </a:solidFill>
+                <a:latin typeface="Calibri"/>
+              </a:rPr>
+              <a:t>triển</a:t>
+            </a:r>
+            <a:r>
+              <a:rPr sz="1150" b="0" dirty="0">
+                <a:solidFill>
+                  <a:srgbClr val="FFD966"/>
+                </a:solidFill>
+                <a:latin typeface="Calibri"/>
+              </a:rPr>
+              <a:t>, </a:t>
+            </a:r>
+            <a:r>
+              <a:rPr sz="1150" b="0" dirty="0" err="1">
+                <a:solidFill>
+                  <a:srgbClr val="FFD966"/>
+                </a:solidFill>
+                <a:latin typeface="Calibri"/>
+              </a:rPr>
+              <a:t>chưa</a:t>
+            </a:r>
+            <a:r>
+              <a:rPr sz="1150" b="0" dirty="0">
+                <a:solidFill>
+                  <a:srgbClr val="FFD966"/>
+                </a:solidFill>
+                <a:latin typeface="Calibri"/>
+              </a:rPr>
+              <a:t> </a:t>
+            </a:r>
+            <a:r>
+              <a:rPr sz="1150" b="0" dirty="0" err="1">
+                <a:solidFill>
+                  <a:srgbClr val="FFD966"/>
+                </a:solidFill>
+                <a:latin typeface="Calibri"/>
+              </a:rPr>
+              <a:t>nằm</a:t>
+            </a:r>
+            <a:r>
+              <a:rPr sz="1150" b="0" dirty="0">
+                <a:solidFill>
+                  <a:srgbClr val="FFD966"/>
+                </a:solidFill>
+                <a:latin typeface="Calibri"/>
+              </a:rPr>
+              <a:t> </a:t>
+            </a:r>
+            <a:r>
+              <a:rPr sz="1150" b="0" dirty="0" err="1">
+                <a:solidFill>
+                  <a:srgbClr val="FFD966"/>
+                </a:solidFill>
+                <a:latin typeface="Calibri"/>
+              </a:rPr>
+              <a:t>trong</a:t>
+            </a:r>
+            <a:r>
+              <a:rPr sz="1150" b="0" dirty="0">
+                <a:solidFill>
+                  <a:srgbClr val="FFD966"/>
+                </a:solidFill>
+                <a:latin typeface="Calibri"/>
+              </a:rPr>
+              <a:t> </a:t>
+            </a:r>
+            <a:r>
+              <a:rPr sz="1150" b="0" dirty="0" err="1">
+                <a:solidFill>
+                  <a:srgbClr val="FFD966"/>
+                </a:solidFill>
+                <a:latin typeface="Calibri"/>
+              </a:rPr>
+              <a:t>kết</a:t>
+            </a:r>
+            <a:r>
+              <a:rPr sz="1150" b="0" dirty="0">
+                <a:solidFill>
+                  <a:srgbClr val="FFD966"/>
+                </a:solidFill>
+                <a:latin typeface="Calibri"/>
+              </a:rPr>
+              <a:t> </a:t>
+            </a:r>
+            <a:r>
+              <a:rPr sz="1150" b="0" dirty="0" err="1">
+                <a:solidFill>
+                  <a:srgbClr val="FFD966"/>
+                </a:solidFill>
+                <a:latin typeface="Calibri"/>
+              </a:rPr>
+              <a:t>quả</a:t>
+            </a:r>
+            <a:r>
+              <a:rPr sz="1150" b="0" dirty="0">
+                <a:solidFill>
+                  <a:srgbClr val="FFD966"/>
+                </a:solidFill>
+                <a:latin typeface="Calibri"/>
+              </a:rPr>
+              <a:t> </a:t>
+            </a:r>
+            <a:r>
+              <a:rPr sz="1150" b="0" dirty="0" err="1">
+                <a:solidFill>
+                  <a:srgbClr val="FFD966"/>
+                </a:solidFill>
+                <a:latin typeface="Calibri"/>
+              </a:rPr>
+              <a:t>báo</a:t>
+            </a:r>
+            <a:r>
+              <a:rPr sz="1150" b="0" dirty="0">
+                <a:solidFill>
+                  <a:srgbClr val="FFD966"/>
+                </a:solidFill>
+                <a:latin typeface="Calibri"/>
+              </a:rPr>
+              <a:t> </a:t>
+            </a:r>
+            <a:r>
+              <a:rPr sz="1150" b="0" dirty="0" err="1">
+                <a:solidFill>
+                  <a:srgbClr val="FFD966"/>
+                </a:solidFill>
+                <a:latin typeface="Calibri"/>
+              </a:rPr>
+              <a:t>cáo</a:t>
+            </a:r>
+            <a:r>
+              <a:rPr sz="1150" b="0" dirty="0">
+                <a:solidFill>
+                  <a:srgbClr val="FFD966"/>
+                </a:solidFill>
+                <a:latin typeface="Calibri"/>
+              </a:rPr>
+              <a:t>.</a:t>
+            </a:r>
+          </a:p>
+        </p:txBody>
+      </p:sp>
+      <p:pic>
+        <p:nvPicPr>
+          <p:cNvPr id="6" name="Hình ảnh 5">
+            <a:extLst>
+              <a:ext uri="{FF2B5EF4-FFF2-40B4-BE49-F238E27FC236}">
+                <a16:creationId xmlns:a16="http://schemas.microsoft.com/office/drawing/2014/main" id="{769ADCBC-ED71-2943-5FE1-8D36003D5061}"/>
+              </a:ext>
+            </a:extLst>
+          </p:cNvPr>
+          <p:cNvPicPr>
+            <a:picLocks noChangeAspect="1"/>
+          </p:cNvPicPr>
+          <p:nvPr/>
+        </p:nvPicPr>
+        <p:blipFill>
+          <a:blip r:embed="rId2"/>
+          <a:stretch>
+            <a:fillRect/>
+          </a:stretch>
+        </p:blipFill>
+        <p:spPr>
+          <a:xfrm>
+            <a:off x="1043341" y="1300525"/>
+            <a:ext cx="6902178" cy="3451089"/>
+          </a:xfrm>
+          <a:prstGeom prst="rect">
+            <a:avLst/>
+          </a:prstGeom>
+        </p:spPr>
+      </p:pic>
     </p:spTree>
   </p:cSld>
   <p:clrMapOvr>
@@ -8188,7 +8874,7 @@
 </file>
 
 <file path=ppt/slides/slide16.xml><?xml version="1.0" encoding="utf-8"?>
-<p:sld xmlns:a="http://schemas.openxmlformats.org/drawingml/2006/main" xmlns:p="http://schemas.openxmlformats.org/presentationml/2006/main" xmlns:r="http://schemas.openxmlformats.org/officeDocument/2006/relationships">
+<p:sld xmlns:a="http://schemas.openxmlformats.org/drawingml/2006/main" xmlns:r="http://schemas.openxmlformats.org/officeDocument/2006/relationships" xmlns:p="http://schemas.openxmlformats.org/presentationml/2006/main">
   <p:cSld>
     <p:spTree>
       <p:nvGrpSpPr>
@@ -8196,7 +8882,14 @@
         <p:cNvGrpSpPr/>
         <p:nvPr/>
       </p:nvGrpSpPr>
-      <p:grpSpPr/>
+      <p:grpSpPr>
+        <a:xfrm>
+          <a:off x="0" y="0"/>
+          <a:ext cx="0" cy="0"/>
+          <a:chOff x="0" y="0"/>
+          <a:chExt cx="0" cy="0"/>
+        </a:xfrm>
+      </p:grpSpPr>
       <p:sp>
         <p:nvSpPr>
           <p:cNvPr id="2" name="Title 1"/>
@@ -8245,8 +8938,20 @@
                 <a:tableStyleId>{5C22544A-7EE6-4342-B048-85BDC9FD1C3A}</a:tableStyleId>
               </a:tblPr>
               <a:tblGrid>
-                <a:gridCol w="3108960"/>
-                <a:gridCol w="1463040"/>
+                <a:gridCol w="3108960">
+                  <a:extLst>
+                    <a:ext uri="{9D8B030D-6E8A-4147-A177-3AD203B41FA5}">
+                      <a16:colId xmlns:a16="http://schemas.microsoft.com/office/drawing/2014/main" val="20000"/>
+                    </a:ext>
+                  </a:extLst>
+                </a:gridCol>
+                <a:gridCol w="1463040">
+                  <a:extLst>
+                    <a:ext uri="{9D8B030D-6E8A-4147-A177-3AD203B41FA5}">
+                      <a16:colId xmlns:a16="http://schemas.microsoft.com/office/drawing/2014/main" val="20001"/>
+                    </a:ext>
+                  </a:extLst>
+                </a:gridCol>
               </a:tblGrid>
               <a:tr h="422910">
                 <a:tc>
@@ -8295,6 +9000,11 @@
                     </a:solidFill>
                   </a:tcPr>
                 </a:tc>
+                <a:extLst>
+                  <a:ext uri="{0D108BD9-81ED-4DB2-BD59-A6C34878D82A}">
+                    <a16:rowId xmlns:a16="http://schemas.microsoft.com/office/drawing/2014/main" val="10000"/>
+                  </a:ext>
+                </a:extLst>
               </a:tr>
               <a:tr h="422910">
                 <a:tc>
@@ -8343,6 +9053,11 @@
                     </a:solidFill>
                   </a:tcPr>
                 </a:tc>
+                <a:extLst>
+                  <a:ext uri="{0D108BD9-81ED-4DB2-BD59-A6C34878D82A}">
+                    <a16:rowId xmlns:a16="http://schemas.microsoft.com/office/drawing/2014/main" val="10001"/>
+                  </a:ext>
+                </a:extLst>
               </a:tr>
               <a:tr h="422910">
                 <a:tc>
@@ -8391,6 +9106,11 @@
                     </a:solidFill>
                   </a:tcPr>
                 </a:tc>
+                <a:extLst>
+                  <a:ext uri="{0D108BD9-81ED-4DB2-BD59-A6C34878D82A}">
+                    <a16:rowId xmlns:a16="http://schemas.microsoft.com/office/drawing/2014/main" val="10002"/>
+                  </a:ext>
+                </a:extLst>
               </a:tr>
               <a:tr h="422910">
                 <a:tc>
@@ -8439,6 +9159,11 @@
                     </a:solidFill>
                   </a:tcPr>
                 </a:tc>
+                <a:extLst>
+                  <a:ext uri="{0D108BD9-81ED-4DB2-BD59-A6C34878D82A}">
+                    <a16:rowId xmlns:a16="http://schemas.microsoft.com/office/drawing/2014/main" val="10003"/>
+                  </a:ext>
+                </a:extLst>
               </a:tr>
             </a:tbl>
           </a:graphicData>
@@ -8461,7 +9186,7 @@
           <a:noFill/>
         </p:spPr>
         <p:txBody>
-          <a:bodyPr wrap="square" lIns="50800" rIns="50800" tIns="25400" bIns="25400">
+          <a:bodyPr wrap="square" lIns="50800" tIns="25400" rIns="50800" bIns="25400">
             <a:spAutoFit/>
           </a:bodyPr>
           <a:lstStyle/>
@@ -8584,7 +9309,7 @@
           <a:noFill/>
         </p:spPr>
         <p:txBody>
-          <a:bodyPr wrap="square" lIns="50800" rIns="50800" tIns="25400" bIns="25400">
+          <a:bodyPr wrap="square" lIns="50800" tIns="25400" rIns="50800" bIns="25400">
             <a:spAutoFit/>
           </a:bodyPr>
           <a:lstStyle/>
@@ -8619,7 +9344,7 @@
 </file>
 
 <file path=ppt/slides/slide17.xml><?xml version="1.0" encoding="utf-8"?>
-<p:sld xmlns:a="http://schemas.openxmlformats.org/drawingml/2006/main" xmlns:p="http://schemas.openxmlformats.org/presentationml/2006/main" xmlns:r="http://schemas.openxmlformats.org/officeDocument/2006/relationships">
+<p:sld xmlns:a="http://schemas.openxmlformats.org/drawingml/2006/main" xmlns:r="http://schemas.openxmlformats.org/officeDocument/2006/relationships" xmlns:p="http://schemas.openxmlformats.org/presentationml/2006/main">
   <p:cSld>
     <p:spTree>
       <p:nvGrpSpPr>
@@ -8627,7 +9352,14 @@
         <p:cNvGrpSpPr/>
         <p:nvPr/>
       </p:nvGrpSpPr>
-      <p:grpSpPr/>
+      <p:grpSpPr>
+        <a:xfrm>
+          <a:off x="0" y="0"/>
+          <a:ext cx="0" cy="0"/>
+          <a:chOff x="0" y="0"/>
+          <a:chExt cx="0" cy="0"/>
+        </a:xfrm>
+      </p:grpSpPr>
       <p:sp>
         <p:nvSpPr>
           <p:cNvPr id="2" name="Title 1"/>
@@ -8696,7 +9428,7 @@
           </a:fontRef>
         </p:style>
         <p:txBody>
-          <a:bodyPr rtlCol="0" anchor="ctr" wrap="square" lIns="76200" rIns="76200" tIns="38100" bIns="38100"/>
+          <a:bodyPr wrap="square" lIns="76200" tIns="38100" rIns="76200" bIns="38100" rtlCol="0" anchor="ctr"/>
           <a:lstStyle/>
           <a:p>
             <a:pPr algn="ctr">
@@ -8737,12 +9469,12 @@
           <a:noFill/>
         </p:spPr>
         <p:txBody>
-          <a:bodyPr wrap="square" lIns="50800" rIns="50800" tIns="25400" bIns="25400">
+          <a:bodyPr wrap="square" lIns="50800" tIns="25400" rIns="50800" bIns="25400">
             <a:spAutoFit/>
           </a:bodyPr>
           <a:lstStyle/>
           <a:p>
-            <a:pPr algn="l" indent="-137160" marL="137160">
+            <a:pPr marL="137160" indent="-137160" algn="l">
               <a:spcBef>
                 <a:spcPts val="200"/>
               </a:spcBef>
@@ -8763,7 +9495,7 @@
             </a:r>
           </a:p>
           <a:p>
-            <a:pPr algn="l" indent="-137160" marL="137160">
+            <a:pPr marL="137160" indent="-137160" algn="l">
               <a:spcBef>
                 <a:spcPts val="200"/>
               </a:spcBef>
@@ -8784,7 +9516,7 @@
             </a:r>
           </a:p>
           <a:p>
-            <a:pPr algn="l" indent="-137160" marL="137160">
+            <a:pPr marL="137160" indent="-137160" algn="l">
               <a:spcBef>
                 <a:spcPts val="200"/>
               </a:spcBef>
@@ -8805,7 +9537,7 @@
             </a:r>
           </a:p>
           <a:p>
-            <a:pPr algn="l" indent="-137160" marL="137160">
+            <a:pPr marL="137160" indent="-137160" algn="l">
               <a:spcBef>
                 <a:spcPts val="200"/>
               </a:spcBef>
@@ -8826,7 +9558,7 @@
             </a:r>
           </a:p>
           <a:p>
-            <a:pPr algn="l" indent="-137160" marL="137160">
+            <a:pPr marL="137160" indent="-137160" algn="l">
               <a:spcBef>
                 <a:spcPts val="200"/>
               </a:spcBef>
@@ -8887,7 +9619,7 @@
           </a:fontRef>
         </p:style>
         <p:txBody>
-          <a:bodyPr rtlCol="0" anchor="ctr" wrap="square" lIns="76200" rIns="76200" tIns="38100" bIns="38100"/>
+          <a:bodyPr wrap="square" lIns="76200" tIns="38100" rIns="76200" bIns="38100" rtlCol="0" anchor="ctr"/>
           <a:lstStyle/>
           <a:p>
             <a:pPr algn="ctr">
@@ -8928,12 +9660,12 @@
           <a:noFill/>
         </p:spPr>
         <p:txBody>
-          <a:bodyPr wrap="square" lIns="50800" rIns="50800" tIns="25400" bIns="25400">
+          <a:bodyPr wrap="square" lIns="50800" tIns="25400" rIns="50800" bIns="25400">
             <a:spAutoFit/>
           </a:bodyPr>
           <a:lstStyle/>
           <a:p>
-            <a:pPr algn="l" indent="-137160" marL="137160">
+            <a:pPr marL="137160" indent="-137160" algn="l">
               <a:spcBef>
                 <a:spcPts val="200"/>
               </a:spcBef>
@@ -8954,7 +9686,7 @@
             </a:r>
           </a:p>
           <a:p>
-            <a:pPr algn="l" indent="-137160" marL="137160">
+            <a:pPr marL="137160" indent="-137160" algn="l">
               <a:spcBef>
                 <a:spcPts val="200"/>
               </a:spcBef>
@@ -8975,7 +9707,7 @@
             </a:r>
           </a:p>
           <a:p>
-            <a:pPr algn="l" indent="-137160" marL="137160">
+            <a:pPr marL="137160" indent="-137160" algn="l">
               <a:spcBef>
                 <a:spcPts val="200"/>
               </a:spcBef>
@@ -8996,7 +9728,7 @@
             </a:r>
           </a:p>
           <a:p>
-            <a:pPr algn="l" indent="-137160" marL="137160">
+            <a:pPr marL="137160" indent="-137160" algn="l">
               <a:spcBef>
                 <a:spcPts val="200"/>
               </a:spcBef>
@@ -9027,7 +9759,7 @@
 </file>
 
 <file path=ppt/slides/slide18.xml><?xml version="1.0" encoding="utf-8"?>
-<p:sld xmlns:a="http://schemas.openxmlformats.org/drawingml/2006/main" xmlns:p="http://schemas.openxmlformats.org/presentationml/2006/main" xmlns:r="http://schemas.openxmlformats.org/officeDocument/2006/relationships">
+<p:sld xmlns:a="http://schemas.openxmlformats.org/drawingml/2006/main" xmlns:r="http://schemas.openxmlformats.org/officeDocument/2006/relationships" xmlns:p="http://schemas.openxmlformats.org/presentationml/2006/main">
   <p:cSld>
     <p:spTree>
       <p:nvGrpSpPr>
@@ -9035,7 +9767,14 @@
         <p:cNvGrpSpPr/>
         <p:nvPr/>
       </p:nvGrpSpPr>
-      <p:grpSpPr/>
+      <p:grpSpPr>
+        <a:xfrm>
+          <a:off x="0" y="0"/>
+          <a:ext cx="0" cy="0"/>
+          <a:chOff x="0" y="0"/>
+          <a:chExt cx="0" cy="0"/>
+        </a:xfrm>
+      </p:grpSpPr>
       <p:sp>
         <p:nvSpPr>
           <p:cNvPr id="2" name="TextBox 1"/>
@@ -9053,7 +9792,7 @@
           <a:noFill/>
         </p:spPr>
         <p:txBody>
-          <a:bodyPr wrap="square" lIns="50800" rIns="50800" tIns="25400" bIns="25400">
+          <a:bodyPr wrap="square" lIns="50800" tIns="25400" rIns="50800" bIns="25400">
             <a:spAutoFit/>
           </a:bodyPr>
           <a:lstStyle/>
@@ -9116,7 +9855,7 @@
           <a:noFill/>
         </p:spPr>
         <p:txBody>
-          <a:bodyPr wrap="square" lIns="50800" rIns="50800" tIns="25400" bIns="25400">
+          <a:bodyPr wrap="square" lIns="50800" tIns="25400" rIns="50800" bIns="25400">
             <a:spAutoFit/>
           </a:bodyPr>
           <a:lstStyle/>
@@ -9151,7 +9890,7 @@
 </file>
 
 <file path=ppt/slides/slide19.xml><?xml version="1.0" encoding="utf-8"?>
-<p:sld xmlns:a="http://schemas.openxmlformats.org/drawingml/2006/main" xmlns:p="http://schemas.openxmlformats.org/presentationml/2006/main" xmlns:r="http://schemas.openxmlformats.org/officeDocument/2006/relationships">
+<p:sld xmlns:a="http://schemas.openxmlformats.org/drawingml/2006/main" xmlns:r="http://schemas.openxmlformats.org/officeDocument/2006/relationships" xmlns:p="http://schemas.openxmlformats.org/presentationml/2006/main">
   <p:cSld>
     <p:spTree>
       <p:nvGrpSpPr>
@@ -9159,7 +9898,14 @@
         <p:cNvGrpSpPr/>
         <p:nvPr/>
       </p:nvGrpSpPr>
-      <p:grpSpPr/>
+      <p:grpSpPr>
+        <a:xfrm>
+          <a:off x="0" y="0"/>
+          <a:ext cx="0" cy="0"/>
+          <a:chOff x="0" y="0"/>
+          <a:chExt cx="0" cy="0"/>
+        </a:xfrm>
+      </p:grpSpPr>
       <p:sp>
         <p:nvSpPr>
           <p:cNvPr id="2" name="Title 1"/>
@@ -9206,7 +9952,7 @@
           <a:noFill/>
         </p:spPr>
         <p:txBody>
-          <a:bodyPr wrap="square" lIns="50800" rIns="50800" tIns="25400" bIns="25400">
+          <a:bodyPr wrap="square" lIns="50800" tIns="25400" rIns="50800" bIns="25400">
             <a:spAutoFit/>
           </a:bodyPr>
           <a:lstStyle/>
@@ -9261,7 +10007,7 @@
 </file>
 
 <file path=ppt/slides/slide2.xml><?xml version="1.0" encoding="utf-8"?>
-<p:sld xmlns:a="http://schemas.openxmlformats.org/drawingml/2006/main" xmlns:p="http://schemas.openxmlformats.org/presentationml/2006/main" xmlns:r="http://schemas.openxmlformats.org/officeDocument/2006/relationships">
+<p:sld xmlns:a="http://schemas.openxmlformats.org/drawingml/2006/main" xmlns:r="http://schemas.openxmlformats.org/officeDocument/2006/relationships" xmlns:p="http://schemas.openxmlformats.org/presentationml/2006/main">
   <p:cSld>
     <p:spTree>
       <p:nvGrpSpPr>
@@ -9269,7 +10015,14 @@
         <p:cNvGrpSpPr/>
         <p:nvPr/>
       </p:nvGrpSpPr>
-      <p:grpSpPr/>
+      <p:grpSpPr>
+        <a:xfrm>
+          <a:off x="0" y="0"/>
+          <a:ext cx="0" cy="0"/>
+          <a:chOff x="0" y="0"/>
+          <a:chExt cx="0" cy="0"/>
+        </a:xfrm>
+      </p:grpSpPr>
       <p:sp>
         <p:nvSpPr>
           <p:cNvPr id="2" name="Title 1"/>
@@ -9338,7 +10091,7 @@
           </a:fontRef>
         </p:style>
         <p:txBody>
-          <a:bodyPr rtlCol="0" anchor="ctr" wrap="square" lIns="76200" rIns="76200" tIns="38100" bIns="38100"/>
+          <a:bodyPr wrap="square" lIns="76200" tIns="38100" rIns="76200" bIns="38100" rtlCol="0" anchor="ctr"/>
           <a:lstStyle/>
           <a:p>
             <a:pPr algn="ctr">
@@ -9379,7 +10132,7 @@
           <a:noFill/>
         </p:spPr>
         <p:txBody>
-          <a:bodyPr wrap="square" lIns="50800" rIns="50800" tIns="25400" bIns="25400">
+          <a:bodyPr wrap="square" lIns="50800" tIns="25400" rIns="50800" bIns="25400">
             <a:spAutoFit/>
           </a:bodyPr>
           <a:lstStyle/>
@@ -9444,7 +10197,7 @@
           </a:fontRef>
         </p:style>
         <p:txBody>
-          <a:bodyPr rtlCol="0" anchor="ctr" wrap="square" lIns="76200" rIns="76200" tIns="38100" bIns="38100"/>
+          <a:bodyPr wrap="square" lIns="76200" tIns="38100" rIns="76200" bIns="38100" rtlCol="0" anchor="ctr"/>
           <a:lstStyle/>
           <a:p>
             <a:pPr algn="ctr">
@@ -9485,7 +10238,7 @@
           <a:noFill/>
         </p:spPr>
         <p:txBody>
-          <a:bodyPr wrap="square" lIns="50800" rIns="50800" tIns="25400" bIns="25400">
+          <a:bodyPr wrap="square" lIns="50800" tIns="25400" rIns="50800" bIns="25400">
             <a:spAutoFit/>
           </a:bodyPr>
           <a:lstStyle/>
@@ -9550,7 +10303,7 @@
           </a:fontRef>
         </p:style>
         <p:txBody>
-          <a:bodyPr rtlCol="0" anchor="ctr" wrap="square" lIns="76200" rIns="76200" tIns="38100" bIns="38100"/>
+          <a:bodyPr wrap="square" lIns="76200" tIns="38100" rIns="76200" bIns="38100" rtlCol="0" anchor="ctr"/>
           <a:lstStyle/>
           <a:p>
             <a:pPr algn="ctr">
@@ -9591,7 +10344,7 @@
           <a:noFill/>
         </p:spPr>
         <p:txBody>
-          <a:bodyPr wrap="square" lIns="50800" rIns="50800" tIns="25400" bIns="25400">
+          <a:bodyPr wrap="square" lIns="50800" tIns="25400" rIns="50800" bIns="25400">
             <a:spAutoFit/>
           </a:bodyPr>
           <a:lstStyle/>
@@ -9656,7 +10409,7 @@
           </a:fontRef>
         </p:style>
         <p:txBody>
-          <a:bodyPr rtlCol="0" anchor="ctr" wrap="square" lIns="76200" rIns="76200" tIns="38100" bIns="38100"/>
+          <a:bodyPr wrap="square" lIns="76200" tIns="38100" rIns="76200" bIns="38100" rtlCol="0" anchor="ctr"/>
           <a:lstStyle/>
           <a:p>
             <a:pPr algn="ctr">
@@ -9697,7 +10450,7 @@
           <a:noFill/>
         </p:spPr>
         <p:txBody>
-          <a:bodyPr wrap="square" lIns="50800" rIns="50800" tIns="25400" bIns="25400">
+          <a:bodyPr wrap="square" lIns="50800" tIns="25400" rIns="50800" bIns="25400">
             <a:spAutoFit/>
           </a:bodyPr>
           <a:lstStyle/>
@@ -9762,7 +10515,7 @@
           </a:fontRef>
         </p:style>
         <p:txBody>
-          <a:bodyPr rtlCol="0" anchor="ctr" wrap="square" lIns="76200" rIns="76200" tIns="38100" bIns="38100"/>
+          <a:bodyPr wrap="square" lIns="76200" tIns="38100" rIns="76200" bIns="38100" rtlCol="0" anchor="ctr"/>
           <a:lstStyle/>
           <a:p>
             <a:pPr algn="ctr">
@@ -9803,7 +10556,7 @@
           <a:noFill/>
         </p:spPr>
         <p:txBody>
-          <a:bodyPr wrap="square" lIns="50800" rIns="50800" tIns="25400" bIns="25400">
+          <a:bodyPr wrap="square" lIns="50800" tIns="25400" rIns="50800" bIns="25400">
             <a:spAutoFit/>
           </a:bodyPr>
           <a:lstStyle/>
@@ -9838,7 +10591,7 @@
 </file>
 
 <file path=ppt/slides/slide20.xml><?xml version="1.0" encoding="utf-8"?>
-<p:sld xmlns:a="http://schemas.openxmlformats.org/drawingml/2006/main" xmlns:p="http://schemas.openxmlformats.org/presentationml/2006/main" xmlns:r="http://schemas.openxmlformats.org/officeDocument/2006/relationships">
+<p:sld xmlns:a="http://schemas.openxmlformats.org/drawingml/2006/main" xmlns:r="http://schemas.openxmlformats.org/officeDocument/2006/relationships" xmlns:p="http://schemas.openxmlformats.org/presentationml/2006/main">
   <p:cSld>
     <p:spTree>
       <p:nvGrpSpPr>
@@ -9846,7 +10599,14 @@
         <p:cNvGrpSpPr/>
         <p:nvPr/>
       </p:nvGrpSpPr>
-      <p:grpSpPr/>
+      <p:grpSpPr>
+        <a:xfrm>
+          <a:off x="0" y="0"/>
+          <a:ext cx="0" cy="0"/>
+          <a:chOff x="0" y="0"/>
+          <a:chExt cx="0" cy="0"/>
+        </a:xfrm>
+      </p:grpSpPr>
       <p:sp>
         <p:nvSpPr>
           <p:cNvPr id="2" name="Title 1"/>
@@ -9922,7 +10682,7 @@
           <a:noFill/>
         </p:spPr>
         <p:txBody>
-          <a:bodyPr wrap="square" lIns="50800" rIns="50800" tIns="25400" bIns="25400">
+          <a:bodyPr wrap="square" lIns="50800" tIns="25400" rIns="50800" bIns="25400">
             <a:spAutoFit/>
           </a:bodyPr>
           <a:lstStyle/>
@@ -9947,7 +10707,7 @@
             </a:r>
           </a:p>
           <a:p>
-            <a:pPr algn="l" indent="-137160" marL="137160">
+            <a:pPr marL="137160" indent="-137160" algn="l">
               <a:spcBef>
                 <a:spcPts val="200"/>
               </a:spcBef>
@@ -9968,7 +10728,7 @@
             </a:r>
           </a:p>
           <a:p>
-            <a:pPr algn="l" indent="-137160" marL="137160">
+            <a:pPr marL="137160" indent="-137160" algn="l">
               <a:spcBef>
                 <a:spcPts val="200"/>
               </a:spcBef>
@@ -9989,7 +10749,7 @@
             </a:r>
           </a:p>
           <a:p>
-            <a:pPr algn="l" indent="-137160" marL="137160">
+            <a:pPr marL="137160" indent="-137160" algn="l">
               <a:spcBef>
                 <a:spcPts val="200"/>
               </a:spcBef>
@@ -10030,7 +10790,7 @@
             </a:r>
           </a:p>
           <a:p>
-            <a:pPr algn="l" indent="-137160" marL="137160">
+            <a:pPr marL="137160" indent="-137160" algn="l">
               <a:spcBef>
                 <a:spcPts val="200"/>
               </a:spcBef>
@@ -10061,7 +10821,7 @@
 </file>
 
 <file path=ppt/slides/slide21.xml><?xml version="1.0" encoding="utf-8"?>
-<p:sld xmlns:a="http://schemas.openxmlformats.org/drawingml/2006/main" xmlns:p="http://schemas.openxmlformats.org/presentationml/2006/main" xmlns:r="http://schemas.openxmlformats.org/officeDocument/2006/relationships">
+<p:sld xmlns:a="http://schemas.openxmlformats.org/drawingml/2006/main" xmlns:r="http://schemas.openxmlformats.org/officeDocument/2006/relationships" xmlns:p="http://schemas.openxmlformats.org/presentationml/2006/main">
   <p:cSld>
     <p:spTree>
       <p:nvGrpSpPr>
@@ -10069,7 +10829,14 @@
         <p:cNvGrpSpPr/>
         <p:nvPr/>
       </p:nvGrpSpPr>
-      <p:grpSpPr/>
+      <p:grpSpPr>
+        <a:xfrm>
+          <a:off x="0" y="0"/>
+          <a:ext cx="0" cy="0"/>
+          <a:chOff x="0" y="0"/>
+          <a:chExt cx="0" cy="0"/>
+        </a:xfrm>
+      </p:grpSpPr>
       <p:sp>
         <p:nvSpPr>
           <p:cNvPr id="2" name="Title 1"/>
@@ -10118,11 +10885,41 @@
                 <a:tableStyleId>{5C22544A-7EE6-4342-B048-85BDC9FD1C3A}</a:tableStyleId>
               </a:tblPr>
               <a:tblGrid>
-                <a:gridCol w="1828800"/>
-                <a:gridCol w="1417320"/>
-                <a:gridCol w="1417320"/>
-                <a:gridCol w="1417320"/>
-                <a:gridCol w="1417320"/>
+                <a:gridCol w="1828800">
+                  <a:extLst>
+                    <a:ext uri="{9D8B030D-6E8A-4147-A177-3AD203B41FA5}">
+                      <a16:colId xmlns:a16="http://schemas.microsoft.com/office/drawing/2014/main" val="20000"/>
+                    </a:ext>
+                  </a:extLst>
+                </a:gridCol>
+                <a:gridCol w="1417320">
+                  <a:extLst>
+                    <a:ext uri="{9D8B030D-6E8A-4147-A177-3AD203B41FA5}">
+                      <a16:colId xmlns:a16="http://schemas.microsoft.com/office/drawing/2014/main" val="20001"/>
+                    </a:ext>
+                  </a:extLst>
+                </a:gridCol>
+                <a:gridCol w="1417320">
+                  <a:extLst>
+                    <a:ext uri="{9D8B030D-6E8A-4147-A177-3AD203B41FA5}">
+                      <a16:colId xmlns:a16="http://schemas.microsoft.com/office/drawing/2014/main" val="20002"/>
+                    </a:ext>
+                  </a:extLst>
+                </a:gridCol>
+                <a:gridCol w="1417320">
+                  <a:extLst>
+                    <a:ext uri="{9D8B030D-6E8A-4147-A177-3AD203B41FA5}">
+                      <a16:colId xmlns:a16="http://schemas.microsoft.com/office/drawing/2014/main" val="20003"/>
+                    </a:ext>
+                  </a:extLst>
+                </a:gridCol>
+                <a:gridCol w="1417320">
+                  <a:extLst>
+                    <a:ext uri="{9D8B030D-6E8A-4147-A177-3AD203B41FA5}">
+                      <a16:colId xmlns:a16="http://schemas.microsoft.com/office/drawing/2014/main" val="20004"/>
+                    </a:ext>
+                  </a:extLst>
+                </a:gridCol>
               </a:tblGrid>
               <a:tr h="365760">
                 <a:tc>
@@ -10240,6 +11037,11 @@
                     </a:solidFill>
                   </a:tcPr>
                 </a:tc>
+                <a:extLst>
+                  <a:ext uri="{0D108BD9-81ED-4DB2-BD59-A6C34878D82A}">
+                    <a16:rowId xmlns:a16="http://schemas.microsoft.com/office/drawing/2014/main" val="10000"/>
+                  </a:ext>
+                </a:extLst>
               </a:tr>
               <a:tr h="365760">
                 <a:tc>
@@ -10357,6 +11159,11 @@
                     </a:solidFill>
                   </a:tcPr>
                 </a:tc>
+                <a:extLst>
+                  <a:ext uri="{0D108BD9-81ED-4DB2-BD59-A6C34878D82A}">
+                    <a16:rowId xmlns:a16="http://schemas.microsoft.com/office/drawing/2014/main" val="10001"/>
+                  </a:ext>
+                </a:extLst>
               </a:tr>
               <a:tr h="365760">
                 <a:tc>
@@ -10474,6 +11281,11 @@
                     </a:solidFill>
                   </a:tcPr>
                 </a:tc>
+                <a:extLst>
+                  <a:ext uri="{0D108BD9-81ED-4DB2-BD59-A6C34878D82A}">
+                    <a16:rowId xmlns:a16="http://schemas.microsoft.com/office/drawing/2014/main" val="10002"/>
+                  </a:ext>
+                </a:extLst>
               </a:tr>
               <a:tr h="365760">
                 <a:tc>
@@ -10591,6 +11403,11 @@
                     </a:solidFill>
                   </a:tcPr>
                 </a:tc>
+                <a:extLst>
+                  <a:ext uri="{0D108BD9-81ED-4DB2-BD59-A6C34878D82A}">
+                    <a16:rowId xmlns:a16="http://schemas.microsoft.com/office/drawing/2014/main" val="10003"/>
+                  </a:ext>
+                </a:extLst>
               </a:tr>
               <a:tr h="365760">
                 <a:tc>
@@ -10708,6 +11525,11 @@
                     </a:solidFill>
                   </a:tcPr>
                 </a:tc>
+                <a:extLst>
+                  <a:ext uri="{0D108BD9-81ED-4DB2-BD59-A6C34878D82A}">
+                    <a16:rowId xmlns:a16="http://schemas.microsoft.com/office/drawing/2014/main" val="10004"/>
+                  </a:ext>
+                </a:extLst>
               </a:tr>
               <a:tr h="365760">
                 <a:tc>
@@ -10825,6 +11647,11 @@
                     </a:solidFill>
                   </a:tcPr>
                 </a:tc>
+                <a:extLst>
+                  <a:ext uri="{0D108BD9-81ED-4DB2-BD59-A6C34878D82A}">
+                    <a16:rowId xmlns:a16="http://schemas.microsoft.com/office/drawing/2014/main" val="10005"/>
+                  </a:ext>
+                </a:extLst>
               </a:tr>
               <a:tr h="365760">
                 <a:tc>
@@ -10942,6 +11769,11 @@
                     </a:solidFill>
                   </a:tcPr>
                 </a:tc>
+                <a:extLst>
+                  <a:ext uri="{0D108BD9-81ED-4DB2-BD59-A6C34878D82A}">
+                    <a16:rowId xmlns:a16="http://schemas.microsoft.com/office/drawing/2014/main" val="10006"/>
+                  </a:ext>
+                </a:extLst>
               </a:tr>
               <a:tr h="365760">
                 <a:tc>
@@ -11059,6 +11891,11 @@
                     </a:solidFill>
                   </a:tcPr>
                 </a:tc>
+                <a:extLst>
+                  <a:ext uri="{0D108BD9-81ED-4DB2-BD59-A6C34878D82A}">
+                    <a16:rowId xmlns:a16="http://schemas.microsoft.com/office/drawing/2014/main" val="10007"/>
+                  </a:ext>
+                </a:extLst>
               </a:tr>
               <a:tr h="365760">
                 <a:tc>
@@ -11176,6 +12013,11 @@
                     </a:solidFill>
                   </a:tcPr>
                 </a:tc>
+                <a:extLst>
+                  <a:ext uri="{0D108BD9-81ED-4DB2-BD59-A6C34878D82A}">
+                    <a16:rowId xmlns:a16="http://schemas.microsoft.com/office/drawing/2014/main" val="10008"/>
+                  </a:ext>
+                </a:extLst>
               </a:tr>
               <a:tr h="365760">
                 <a:tc>
@@ -11293,6 +12135,11 @@
                     </a:solidFill>
                   </a:tcPr>
                 </a:tc>
+                <a:extLst>
+                  <a:ext uri="{0D108BD9-81ED-4DB2-BD59-A6C34878D82A}">
+                    <a16:rowId xmlns:a16="http://schemas.microsoft.com/office/drawing/2014/main" val="10009"/>
+                  </a:ext>
+                </a:extLst>
               </a:tr>
             </a:tbl>
           </a:graphicData>
@@ -11315,7 +12162,7 @@
           <a:noFill/>
         </p:spPr>
         <p:txBody>
-          <a:bodyPr wrap="square" lIns="50800" rIns="50800" tIns="25400" bIns="25400">
+          <a:bodyPr wrap="square" lIns="50800" tIns="25400" rIns="50800" bIns="25400">
             <a:spAutoFit/>
           </a:bodyPr>
           <a:lstStyle/>
@@ -11350,7 +12197,7 @@
 </file>
 
 <file path=ppt/slides/slide3.xml><?xml version="1.0" encoding="utf-8"?>
-<p:sld xmlns:a="http://schemas.openxmlformats.org/drawingml/2006/main" xmlns:p="http://schemas.openxmlformats.org/presentationml/2006/main" xmlns:r="http://schemas.openxmlformats.org/officeDocument/2006/relationships">
+<p:sld xmlns:a="http://schemas.openxmlformats.org/drawingml/2006/main" xmlns:r="http://schemas.openxmlformats.org/officeDocument/2006/relationships" xmlns:p="http://schemas.openxmlformats.org/presentationml/2006/main">
   <p:cSld>
     <p:spTree>
       <p:nvGrpSpPr>
@@ -11358,7 +12205,14 @@
         <p:cNvGrpSpPr/>
         <p:nvPr/>
       </p:nvGrpSpPr>
-      <p:grpSpPr/>
+      <p:grpSpPr>
+        <a:xfrm>
+          <a:off x="0" y="0"/>
+          <a:ext cx="0" cy="0"/>
+          <a:chOff x="0" y="0"/>
+          <a:chExt cx="0" cy="0"/>
+        </a:xfrm>
+      </p:grpSpPr>
       <p:sp>
         <p:nvSpPr>
           <p:cNvPr id="2" name="Title 1"/>
@@ -11427,7 +12281,7 @@
           </a:fontRef>
         </p:style>
         <p:txBody>
-          <a:bodyPr rtlCol="0" anchor="ctr" wrap="square" lIns="76200" rIns="76200" tIns="38100" bIns="38100"/>
+          <a:bodyPr wrap="square" lIns="76200" tIns="38100" rIns="76200" bIns="38100" rtlCol="0" anchor="ctr"/>
           <a:lstStyle/>
           <a:p>
             <a:pPr algn="ctr">
@@ -11492,7 +12346,7 @@
           </a:fontRef>
         </p:style>
         <p:txBody>
-          <a:bodyPr rtlCol="0" anchor="ctr" wrap="square" lIns="76200" rIns="76200" tIns="38100" bIns="38100"/>
+          <a:bodyPr wrap="square" lIns="76200" tIns="38100" rIns="76200" bIns="38100" rtlCol="0" anchor="ctr"/>
           <a:lstStyle/>
           <a:p>
             <a:pPr algn="ctr">
@@ -11577,7 +12431,7 @@
           </a:fontRef>
         </p:style>
         <p:txBody>
-          <a:bodyPr rtlCol="0" anchor="ctr" wrap="square" lIns="76200" rIns="76200" tIns="38100" bIns="38100"/>
+          <a:bodyPr wrap="square" lIns="76200" tIns="38100" rIns="76200" bIns="38100" rtlCol="0" anchor="ctr"/>
           <a:lstStyle/>
           <a:p>
             <a:pPr algn="ctr">
@@ -11638,7 +12492,7 @@
           <a:noFill/>
         </p:spPr>
         <p:txBody>
-          <a:bodyPr wrap="square" lIns="50800" rIns="50800" tIns="25400" bIns="25400">
+          <a:bodyPr wrap="square" lIns="50800" tIns="25400" rIns="50800" bIns="25400">
             <a:spAutoFit/>
           </a:bodyPr>
           <a:lstStyle/>
@@ -11683,7 +12537,7 @@
             </a:r>
           </a:p>
           <a:p>
-            <a:pPr algn="l" indent="-137160" marL="137160">
+            <a:pPr marL="137160" indent="-137160" algn="l">
               <a:spcBef>
                 <a:spcPts val="200"/>
               </a:spcBef>
@@ -11704,7 +12558,7 @@
             </a:r>
           </a:p>
           <a:p>
-            <a:pPr algn="l" indent="-137160" marL="137160">
+            <a:pPr marL="137160" indent="-137160" algn="l">
               <a:spcBef>
                 <a:spcPts val="200"/>
               </a:spcBef>
@@ -11725,7 +12579,7 @@
             </a:r>
           </a:p>
           <a:p>
-            <a:pPr algn="l" indent="-137160" marL="137160">
+            <a:pPr marL="137160" indent="-137160" algn="l">
               <a:spcBef>
                 <a:spcPts val="200"/>
               </a:spcBef>
@@ -11786,7 +12640,7 @@
           </a:fontRef>
         </p:style>
         <p:txBody>
-          <a:bodyPr rtlCol="0" anchor="ctr" wrap="square" lIns="76200" rIns="76200" tIns="38100" bIns="38100"/>
+          <a:bodyPr wrap="square" lIns="76200" tIns="38100" rIns="76200" bIns="38100" rtlCol="0" anchor="ctr"/>
           <a:lstStyle/>
           <a:p>
             <a:pPr algn="ctr">
@@ -11849,7 +12703,7 @@
           </a:fontRef>
         </p:style>
         <p:txBody>
-          <a:bodyPr rtlCol="0" anchor="ctr" wrap="square" lIns="76200" rIns="76200" tIns="38100" bIns="38100"/>
+          <a:bodyPr wrap="square" lIns="76200" tIns="38100" rIns="76200" bIns="38100" rtlCol="0" anchor="ctr"/>
           <a:lstStyle/>
           <a:p>
             <a:pPr algn="ctr">
@@ -11914,7 +12768,7 @@
           </a:fontRef>
         </p:style>
         <p:txBody>
-          <a:bodyPr rtlCol="0" anchor="ctr" wrap="square" lIns="76200" rIns="76200" tIns="38100" bIns="38100"/>
+          <a:bodyPr wrap="square" lIns="76200" tIns="38100" rIns="76200" bIns="38100" rtlCol="0" anchor="ctr"/>
           <a:lstStyle/>
           <a:p>
             <a:pPr algn="l">
@@ -11977,7 +12831,7 @@
           </a:fontRef>
         </p:style>
         <p:txBody>
-          <a:bodyPr rtlCol="0" anchor="ctr" wrap="square" lIns="76200" rIns="76200" tIns="38100" bIns="38100"/>
+          <a:bodyPr wrap="square" lIns="76200" tIns="38100" rIns="76200" bIns="38100" rtlCol="0" anchor="ctr"/>
           <a:lstStyle/>
           <a:p>
             <a:pPr algn="ctr">
@@ -12042,7 +12896,7 @@
           </a:fontRef>
         </p:style>
         <p:txBody>
-          <a:bodyPr rtlCol="0" anchor="ctr" wrap="square" lIns="76200" rIns="76200" tIns="38100" bIns="38100"/>
+          <a:bodyPr wrap="square" lIns="76200" tIns="38100" rIns="76200" bIns="38100" rtlCol="0" anchor="ctr"/>
           <a:lstStyle/>
           <a:p>
             <a:pPr algn="l">
@@ -12105,7 +12959,7 @@
           </a:fontRef>
         </p:style>
         <p:txBody>
-          <a:bodyPr rtlCol="0" anchor="ctr" wrap="square" lIns="76200" rIns="76200" tIns="38100" bIns="38100"/>
+          <a:bodyPr wrap="square" lIns="76200" tIns="38100" rIns="76200" bIns="38100" rtlCol="0" anchor="ctr"/>
           <a:lstStyle/>
           <a:p>
             <a:pPr algn="ctr">
@@ -12170,7 +13024,7 @@
           </a:fontRef>
         </p:style>
         <p:txBody>
-          <a:bodyPr rtlCol="0" anchor="ctr" wrap="square" lIns="76200" rIns="76200" tIns="38100" bIns="38100"/>
+          <a:bodyPr wrap="square" lIns="76200" tIns="38100" rIns="76200" bIns="38100" rtlCol="0" anchor="ctr"/>
           <a:lstStyle/>
           <a:p>
             <a:pPr algn="l">
@@ -12203,7 +13057,7 @@
 </file>
 
 <file path=ppt/slides/slide4.xml><?xml version="1.0" encoding="utf-8"?>
-<p:sld xmlns:a="http://schemas.openxmlformats.org/drawingml/2006/main" xmlns:p="http://schemas.openxmlformats.org/presentationml/2006/main" xmlns:r="http://schemas.openxmlformats.org/officeDocument/2006/relationships">
+<p:sld xmlns:a="http://schemas.openxmlformats.org/drawingml/2006/main" xmlns:r="http://schemas.openxmlformats.org/officeDocument/2006/relationships" xmlns:p="http://schemas.openxmlformats.org/presentationml/2006/main">
   <p:cSld>
     <p:spTree>
       <p:nvGrpSpPr>
@@ -12211,7 +13065,14 @@
         <p:cNvGrpSpPr/>
         <p:nvPr/>
       </p:nvGrpSpPr>
-      <p:grpSpPr/>
+      <p:grpSpPr>
+        <a:xfrm>
+          <a:off x="0" y="0"/>
+          <a:ext cx="0" cy="0"/>
+          <a:chOff x="0" y="0"/>
+          <a:chExt cx="0" cy="0"/>
+        </a:xfrm>
+      </p:grpSpPr>
       <p:sp>
         <p:nvSpPr>
           <p:cNvPr id="2" name="Title 1"/>
@@ -12284,6 +13145,7 @@
           <a:lstStyle/>
           <a:p>
             <a:pPr algn="ctr"/>
+            <a:endParaRPr/>
           </a:p>
         </p:txBody>
       </p:sp>
@@ -12328,7 +13190,7 @@
           </a:fontRef>
         </p:style>
         <p:txBody>
-          <a:bodyPr rtlCol="0" anchor="ctr" wrap="square" lIns="76200" rIns="76200" tIns="38100" bIns="38100"/>
+          <a:bodyPr wrap="square" lIns="76200" tIns="38100" rIns="76200" bIns="38100" rtlCol="0" anchor="ctr"/>
           <a:lstStyle/>
           <a:p>
             <a:pPr algn="l">
@@ -12435,6 +13297,7 @@
           <a:lstStyle/>
           <a:p>
             <a:pPr algn="ctr"/>
+            <a:endParaRPr/>
           </a:p>
         </p:txBody>
       </p:sp>
@@ -12479,7 +13342,7 @@
           </a:fontRef>
         </p:style>
         <p:txBody>
-          <a:bodyPr rtlCol="0" anchor="ctr" wrap="square" lIns="76200" rIns="76200" tIns="38100" bIns="38100"/>
+          <a:bodyPr wrap="square" lIns="76200" tIns="38100" rIns="76200" bIns="38100" rtlCol="0" anchor="ctr"/>
           <a:lstStyle/>
           <a:p>
             <a:pPr algn="l">
@@ -12586,6 +13449,7 @@
           <a:lstStyle/>
           <a:p>
             <a:pPr algn="ctr"/>
+            <a:endParaRPr/>
           </a:p>
         </p:txBody>
       </p:sp>
@@ -12630,7 +13494,7 @@
           </a:fontRef>
         </p:style>
         <p:txBody>
-          <a:bodyPr rtlCol="0" anchor="ctr" wrap="square" lIns="76200" rIns="76200" tIns="38100" bIns="38100"/>
+          <a:bodyPr wrap="square" lIns="76200" tIns="38100" rIns="76200" bIns="38100" rtlCol="0" anchor="ctr"/>
           <a:lstStyle/>
           <a:p>
             <a:pPr algn="l">
@@ -12711,7 +13575,7 @@
           <a:noFill/>
         </p:spPr>
         <p:txBody>
-          <a:bodyPr wrap="square" lIns="50800" rIns="50800" tIns="25400" bIns="25400">
+          <a:bodyPr wrap="square" lIns="50800" tIns="25400" rIns="50800" bIns="25400">
             <a:spAutoFit/>
           </a:bodyPr>
           <a:lstStyle/>
@@ -12746,7 +13610,7 @@
 </file>
 
 <file path=ppt/slides/slide5.xml><?xml version="1.0" encoding="utf-8"?>
-<p:sld xmlns:a="http://schemas.openxmlformats.org/drawingml/2006/main" xmlns:p="http://schemas.openxmlformats.org/presentationml/2006/main" xmlns:r="http://schemas.openxmlformats.org/officeDocument/2006/relationships">
+<p:sld xmlns:a="http://schemas.openxmlformats.org/drawingml/2006/main" xmlns:r="http://schemas.openxmlformats.org/officeDocument/2006/relationships" xmlns:p="http://schemas.openxmlformats.org/presentationml/2006/main">
   <p:cSld>
     <p:spTree>
       <p:nvGrpSpPr>
@@ -12754,7 +13618,14 @@
         <p:cNvGrpSpPr/>
         <p:nvPr/>
       </p:nvGrpSpPr>
-      <p:grpSpPr/>
+      <p:grpSpPr>
+        <a:xfrm>
+          <a:off x="0" y="0"/>
+          <a:ext cx="0" cy="0"/>
+          <a:chOff x="0" y="0"/>
+          <a:chExt cx="0" cy="0"/>
+        </a:xfrm>
+      </p:grpSpPr>
       <p:sp>
         <p:nvSpPr>
           <p:cNvPr id="2" name="Title 1"/>
@@ -12803,9 +13674,27 @@
                 <a:tableStyleId>{5C22544A-7EE6-4342-B048-85BDC9FD1C3A}</a:tableStyleId>
               </a:tblPr>
               <a:tblGrid>
-                <a:gridCol w="2286000"/>
-                <a:gridCol w="3108960"/>
-                <a:gridCol w="2834640"/>
+                <a:gridCol w="2286000">
+                  <a:extLst>
+                    <a:ext uri="{9D8B030D-6E8A-4147-A177-3AD203B41FA5}">
+                      <a16:colId xmlns:a16="http://schemas.microsoft.com/office/drawing/2014/main" val="20000"/>
+                    </a:ext>
+                  </a:extLst>
+                </a:gridCol>
+                <a:gridCol w="3108960">
+                  <a:extLst>
+                    <a:ext uri="{9D8B030D-6E8A-4147-A177-3AD203B41FA5}">
+                      <a16:colId xmlns:a16="http://schemas.microsoft.com/office/drawing/2014/main" val="20001"/>
+                    </a:ext>
+                  </a:extLst>
+                </a:gridCol>
+                <a:gridCol w="2834640">
+                  <a:extLst>
+                    <a:ext uri="{9D8B030D-6E8A-4147-A177-3AD203B41FA5}">
+                      <a16:colId xmlns:a16="http://schemas.microsoft.com/office/drawing/2014/main" val="20002"/>
+                    </a:ext>
+                  </a:extLst>
+                </a:gridCol>
               </a:tblGrid>
               <a:tr h="525780">
                 <a:tc>
@@ -12877,6 +13766,11 @@
                     </a:solidFill>
                   </a:tcPr>
                 </a:tc>
+                <a:extLst>
+                  <a:ext uri="{0D108BD9-81ED-4DB2-BD59-A6C34878D82A}">
+                    <a16:rowId xmlns:a16="http://schemas.microsoft.com/office/drawing/2014/main" val="10000"/>
+                  </a:ext>
+                </a:extLst>
               </a:tr>
               <a:tr h="525780">
                 <a:tc>
@@ -12948,6 +13842,11 @@
                     </a:solidFill>
                   </a:tcPr>
                 </a:tc>
+                <a:extLst>
+                  <a:ext uri="{0D108BD9-81ED-4DB2-BD59-A6C34878D82A}">
+                    <a16:rowId xmlns:a16="http://schemas.microsoft.com/office/drawing/2014/main" val="10001"/>
+                  </a:ext>
+                </a:extLst>
               </a:tr>
               <a:tr h="525780">
                 <a:tc>
@@ -13019,6 +13918,11 @@
                     </a:solidFill>
                   </a:tcPr>
                 </a:tc>
+                <a:extLst>
+                  <a:ext uri="{0D108BD9-81ED-4DB2-BD59-A6C34878D82A}">
+                    <a16:rowId xmlns:a16="http://schemas.microsoft.com/office/drawing/2014/main" val="10002"/>
+                  </a:ext>
+                </a:extLst>
               </a:tr>
               <a:tr h="525780">
                 <a:tc>
@@ -13090,6 +13994,11 @@
                     </a:solidFill>
                   </a:tcPr>
                 </a:tc>
+                <a:extLst>
+                  <a:ext uri="{0D108BD9-81ED-4DB2-BD59-A6C34878D82A}">
+                    <a16:rowId xmlns:a16="http://schemas.microsoft.com/office/drawing/2014/main" val="10003"/>
+                  </a:ext>
+                </a:extLst>
               </a:tr>
             </a:tbl>
           </a:graphicData>
@@ -13134,7 +14043,7 @@
           </a:fontRef>
         </p:style>
         <p:txBody>
-          <a:bodyPr rtlCol="0" anchor="ctr" wrap="square" lIns="76200" rIns="76200" tIns="38100" bIns="38100"/>
+          <a:bodyPr wrap="square" lIns="76200" tIns="38100" rIns="76200" bIns="38100" rtlCol="0" anchor="ctr"/>
           <a:lstStyle/>
           <a:p>
             <a:pPr algn="ctr">
@@ -13207,7 +14116,7 @@
 </file>
 
 <file path=ppt/slides/slide6.xml><?xml version="1.0" encoding="utf-8"?>
-<p:sld xmlns:a="http://schemas.openxmlformats.org/drawingml/2006/main" xmlns:p="http://schemas.openxmlformats.org/presentationml/2006/main" xmlns:r="http://schemas.openxmlformats.org/officeDocument/2006/relationships">
+<p:sld xmlns:a="http://schemas.openxmlformats.org/drawingml/2006/main" xmlns:r="http://schemas.openxmlformats.org/officeDocument/2006/relationships" xmlns:p="http://schemas.openxmlformats.org/presentationml/2006/main">
   <p:cSld>
     <p:spTree>
       <p:nvGrpSpPr>
@@ -13215,7 +14124,14 @@
         <p:cNvGrpSpPr/>
         <p:nvPr/>
       </p:nvGrpSpPr>
-      <p:grpSpPr/>
+      <p:grpSpPr>
+        <a:xfrm>
+          <a:off x="0" y="0"/>
+          <a:ext cx="0" cy="0"/>
+          <a:chOff x="0" y="0"/>
+          <a:chExt cx="0" cy="0"/>
+        </a:xfrm>
+      </p:grpSpPr>
       <p:sp>
         <p:nvSpPr>
           <p:cNvPr id="2" name="Title 1"/>
@@ -13262,7 +14178,7 @@
           <a:noFill/>
         </p:spPr>
         <p:txBody>
-          <a:bodyPr wrap="square" lIns="50800" rIns="50800" tIns="25400" bIns="25400">
+          <a:bodyPr wrap="square" lIns="50800" tIns="25400" rIns="50800" bIns="25400">
             <a:spAutoFit/>
           </a:bodyPr>
           <a:lstStyle/>
@@ -13327,7 +14243,7 @@
           </a:fontRef>
         </p:style>
         <p:txBody>
-          <a:bodyPr rtlCol="0" anchor="ctr" wrap="square" lIns="76200" rIns="76200" tIns="38100" bIns="38100"/>
+          <a:bodyPr wrap="square" lIns="76200" tIns="38100" rIns="76200" bIns="38100" rtlCol="0" anchor="ctr"/>
           <a:lstStyle/>
           <a:p>
             <a:pPr algn="ctr">
@@ -13412,6 +14328,7 @@
           <a:lstStyle/>
           <a:p>
             <a:pPr algn="ctr"/>
+            <a:endParaRPr/>
           </a:p>
         </p:txBody>
       </p:sp>
@@ -13454,7 +14371,7 @@
           </a:fontRef>
         </p:style>
         <p:txBody>
-          <a:bodyPr rtlCol="0" anchor="ctr" wrap="square" lIns="76200" rIns="76200" tIns="38100" bIns="38100"/>
+          <a:bodyPr wrap="square" lIns="76200" tIns="38100" rIns="76200" bIns="38100" rtlCol="0" anchor="ctr"/>
           <a:lstStyle/>
           <a:p>
             <a:pPr algn="ctr">
@@ -13539,6 +14456,7 @@
           <a:lstStyle/>
           <a:p>
             <a:pPr algn="ctr"/>
+            <a:endParaRPr/>
           </a:p>
         </p:txBody>
       </p:sp>
@@ -13581,7 +14499,7 @@
           </a:fontRef>
         </p:style>
         <p:txBody>
-          <a:bodyPr rtlCol="0" anchor="ctr" wrap="square" lIns="76200" rIns="76200" tIns="38100" bIns="38100"/>
+          <a:bodyPr wrap="square" lIns="76200" tIns="38100" rIns="76200" bIns="38100" rtlCol="0" anchor="ctr"/>
           <a:lstStyle/>
           <a:p>
             <a:pPr algn="ctr">
@@ -13666,6 +14584,7 @@
           <a:lstStyle/>
           <a:p>
             <a:pPr algn="ctr"/>
+            <a:endParaRPr/>
           </a:p>
         </p:txBody>
       </p:sp>
@@ -13708,7 +14627,7 @@
           </a:fontRef>
         </p:style>
         <p:txBody>
-          <a:bodyPr rtlCol="0" anchor="ctr" wrap="square" lIns="76200" rIns="76200" tIns="38100" bIns="38100"/>
+          <a:bodyPr wrap="square" lIns="76200" tIns="38100" rIns="76200" bIns="38100" rtlCol="0" anchor="ctr"/>
           <a:lstStyle/>
           <a:p>
             <a:pPr algn="ctr">
@@ -13793,6 +14712,7 @@
           <a:lstStyle/>
           <a:p>
             <a:pPr algn="ctr"/>
+            <a:endParaRPr/>
           </a:p>
         </p:txBody>
       </p:sp>
@@ -13835,7 +14755,7 @@
           </a:fontRef>
         </p:style>
         <p:txBody>
-          <a:bodyPr rtlCol="0" anchor="ctr" wrap="square" lIns="76200" rIns="76200" tIns="38100" bIns="38100"/>
+          <a:bodyPr wrap="square" lIns="76200" tIns="38100" rIns="76200" bIns="38100" rtlCol="0" anchor="ctr"/>
           <a:lstStyle/>
           <a:p>
             <a:pPr algn="ctr">
@@ -13896,7 +14816,7 @@
           <a:noFill/>
         </p:spPr>
         <p:txBody>
-          <a:bodyPr wrap="square" lIns="50800" rIns="50800" tIns="25400" bIns="25400">
+          <a:bodyPr wrap="square" lIns="50800" tIns="25400" rIns="50800" bIns="25400">
             <a:spAutoFit/>
           </a:bodyPr>
           <a:lstStyle/>
@@ -13930,7 +14850,7 @@
         </p:nvSpPr>
         <p:spPr>
           <a:xfrm>
-            <a:off x="914400" y="3383280"/>
+            <a:off x="356616" y="3429000"/>
             <a:ext cx="2286000" cy="914400"/>
           </a:xfrm>
           <a:prstGeom prst="roundRect">
@@ -13961,7 +14881,7 @@
           </a:fontRef>
         </p:style>
         <p:txBody>
-          <a:bodyPr rtlCol="0" anchor="ctr" wrap="square" lIns="76200" rIns="76200" tIns="38100" bIns="38100"/>
+          <a:bodyPr wrap="square" lIns="76200" tIns="38100" rIns="76200" bIns="38100" rtlCol="0" anchor="ctr"/>
           <a:lstStyle/>
           <a:p>
             <a:pPr algn="ctr">
@@ -14013,7 +14933,7 @@
         </p:nvSpPr>
         <p:spPr>
           <a:xfrm>
-            <a:off x="3246120" y="3694176"/>
+            <a:off x="2688336" y="3739896"/>
             <a:ext cx="594360" cy="292608"/>
           </a:xfrm>
           <a:prstGeom prst="rightArrow">
@@ -14046,6 +14966,7 @@
           <a:lstStyle/>
           <a:p>
             <a:pPr algn="ctr"/>
+            <a:endParaRPr/>
           </a:p>
         </p:txBody>
       </p:sp>
@@ -14057,7 +14978,7 @@
         </p:nvSpPr>
         <p:spPr>
           <a:xfrm>
-            <a:off x="3886200" y="3383280"/>
+            <a:off x="3328416" y="3429000"/>
             <a:ext cx="2286000" cy="914400"/>
           </a:xfrm>
           <a:prstGeom prst="roundRect">
@@ -14088,7 +15009,7 @@
           </a:fontRef>
         </p:style>
         <p:txBody>
-          <a:bodyPr rtlCol="0" anchor="ctr" wrap="square" lIns="76200" rIns="76200" tIns="38100" bIns="38100"/>
+          <a:bodyPr wrap="square" lIns="76200" tIns="38100" rIns="76200" bIns="38100" rtlCol="0" anchor="ctr"/>
           <a:lstStyle/>
           <a:p>
             <a:pPr algn="ctr">
@@ -14140,7 +15061,7 @@
         </p:nvSpPr>
         <p:spPr>
           <a:xfrm>
-            <a:off x="6217920" y="3694176"/>
+            <a:off x="5660136" y="3739896"/>
             <a:ext cx="594360" cy="292608"/>
           </a:xfrm>
           <a:prstGeom prst="rightArrow">
@@ -14173,6 +15094,7 @@
           <a:lstStyle/>
           <a:p>
             <a:pPr algn="ctr"/>
+            <a:endParaRPr/>
           </a:p>
         </p:txBody>
       </p:sp>
@@ -14184,7 +15106,7 @@
         </p:nvSpPr>
         <p:spPr>
           <a:xfrm>
-            <a:off x="6858000" y="3383280"/>
+            <a:off x="6300216" y="3429000"/>
             <a:ext cx="2286000" cy="914400"/>
           </a:xfrm>
           <a:prstGeom prst="roundRect">
@@ -14215,7 +15137,7 @@
           </a:fontRef>
         </p:style>
         <p:txBody>
-          <a:bodyPr rtlCol="0" anchor="ctr" wrap="square" lIns="76200" rIns="76200" tIns="38100" bIns="38100"/>
+          <a:bodyPr wrap="square" lIns="76200" tIns="38100" rIns="76200" bIns="38100" rtlCol="0" anchor="ctr"/>
           <a:lstStyle/>
           <a:p>
             <a:pPr algn="ctr">
@@ -14255,49 +15177,6 @@
                 <a:latin typeface="Calibri"/>
               </a:rPr>
               <a:t>Macro F1 0,92</a:t>
-            </a:r>
-          </a:p>
-        </p:txBody>
-      </p:sp>
-      <p:sp>
-        <p:nvSpPr>
-          <p:cNvPr id="19" name="TextBox 18"/>
-          <p:cNvSpPr txBox="1"/>
-          <p:nvPr/>
-        </p:nvSpPr>
-        <p:spPr>
-          <a:xfrm>
-            <a:off x="457200" y="4526280"/>
-            <a:ext cx="8229600" cy="457200"/>
-          </a:xfrm>
-          <a:prstGeom prst="rect">
-            <a:avLst/>
-          </a:prstGeom>
-          <a:noFill/>
-        </p:spPr>
-        <p:txBody>
-          <a:bodyPr wrap="square" lIns="50800" rIns="50800" tIns="25400" bIns="25400">
-            <a:spAutoFit/>
-          </a:bodyPr>
-          <a:lstStyle/>
-          <a:p>
-            <a:pPr algn="ctr">
-              <a:spcBef>
-                <a:spcPts val="200"/>
-              </a:spcBef>
-              <a:spcAft>
-                <a:spcPts val="300"/>
-              </a:spcAft>
-              <a:buNone/>
-            </a:pPr>
-            <a:r>
-              <a:rPr sz="1200" b="0" i="1">
-                <a:solidFill>
-                  <a:srgbClr val="606060"/>
-                </a:solidFill>
-                <a:latin typeface="Calibri"/>
-              </a:rPr>
-              <a:t>Các slide sau đi sâu từng khối.</a:t>
             </a:r>
           </a:p>
         </p:txBody>
@@ -14311,7 +15190,7 @@
 </file>
 
 <file path=ppt/slides/slide7.xml><?xml version="1.0" encoding="utf-8"?>
-<p:sld xmlns:a="http://schemas.openxmlformats.org/drawingml/2006/main" xmlns:p="http://schemas.openxmlformats.org/presentationml/2006/main" xmlns:r="http://schemas.openxmlformats.org/officeDocument/2006/relationships">
+<p:sld xmlns:a="http://schemas.openxmlformats.org/drawingml/2006/main" xmlns:r="http://schemas.openxmlformats.org/officeDocument/2006/relationships" xmlns:p="http://schemas.openxmlformats.org/presentationml/2006/main">
   <p:cSld>
     <p:spTree>
       <p:nvGrpSpPr>
@@ -14319,7 +15198,14 @@
         <p:cNvGrpSpPr/>
         <p:nvPr/>
       </p:nvGrpSpPr>
-      <p:grpSpPr/>
+      <p:grpSpPr>
+        <a:xfrm>
+          <a:off x="0" y="0"/>
+          <a:ext cx="0" cy="0"/>
+          <a:chOff x="0" y="0"/>
+          <a:chExt cx="0" cy="0"/>
+        </a:xfrm>
+      </p:grpSpPr>
       <p:sp>
         <p:nvSpPr>
           <p:cNvPr id="2" name="Title 1"/>
@@ -14388,7 +15274,7 @@
           </a:fontRef>
         </p:style>
         <p:txBody>
-          <a:bodyPr rtlCol="0" anchor="ctr" wrap="square" lIns="76200" rIns="76200" tIns="38100" bIns="38100"/>
+          <a:bodyPr wrap="square" lIns="76200" tIns="38100" rIns="76200" bIns="38100" rtlCol="0" anchor="ctr"/>
           <a:lstStyle/>
           <a:p>
             <a:pPr algn="ctr">
@@ -14429,7 +15315,7 @@
           <a:noFill/>
         </p:spPr>
         <p:txBody>
-          <a:bodyPr wrap="square" lIns="50800" rIns="50800" tIns="25400" bIns="25400">
+          <a:bodyPr wrap="square" lIns="50800" tIns="25400" rIns="50800" bIns="25400">
             <a:spAutoFit/>
           </a:bodyPr>
           <a:lstStyle/>
@@ -14454,7 +15340,7 @@
             </a:r>
           </a:p>
           <a:p>
-            <a:pPr algn="l" indent="-137160" marL="137160">
+            <a:pPr marL="137160" indent="-137160" algn="l">
               <a:spcBef>
                 <a:spcPts val="200"/>
               </a:spcBef>
@@ -14475,7 +15361,7 @@
             </a:r>
           </a:p>
           <a:p>
-            <a:pPr algn="l" indent="-137160" marL="137160">
+            <a:pPr marL="137160" indent="-137160" algn="l">
               <a:spcBef>
                 <a:spcPts val="200"/>
               </a:spcBef>
@@ -14516,7 +15402,7 @@
             </a:r>
           </a:p>
           <a:p>
-            <a:pPr algn="l" indent="-137160" marL="137160">
+            <a:pPr marL="137160" indent="-137160" algn="l">
               <a:spcBef>
                 <a:spcPts val="200"/>
               </a:spcBef>
@@ -14579,7 +15465,7 @@
           </a:fontRef>
         </p:style>
         <p:txBody>
-          <a:bodyPr rtlCol="0" anchor="ctr" wrap="square" lIns="76200" rIns="76200" tIns="38100" bIns="38100"/>
+          <a:bodyPr wrap="square" lIns="76200" tIns="38100" rIns="76200" bIns="38100" rtlCol="0" anchor="ctr"/>
           <a:lstStyle/>
           <a:p>
             <a:pPr algn="ctr">
@@ -14649,7 +15535,7 @@
           <a:noFill/>
         </p:spPr>
         <p:txBody>
-          <a:bodyPr wrap="square" lIns="50800" rIns="50800" tIns="25400" bIns="25400">
+          <a:bodyPr wrap="square" lIns="50800" tIns="25400" rIns="50800" bIns="25400">
             <a:spAutoFit/>
           </a:bodyPr>
           <a:lstStyle/>
@@ -14714,7 +15600,7 @@
           </a:fontRef>
         </p:style>
         <p:txBody>
-          <a:bodyPr rtlCol="0" anchor="ctr" wrap="square" lIns="76200" rIns="76200" tIns="38100" bIns="38100"/>
+          <a:bodyPr wrap="square" lIns="76200" tIns="38100" rIns="76200" bIns="38100" rtlCol="0" anchor="ctr"/>
           <a:lstStyle/>
           <a:p>
             <a:pPr algn="ctr">
@@ -14747,7 +15633,7 @@
 </file>
 
 <file path=ppt/slides/slide8.xml><?xml version="1.0" encoding="utf-8"?>
-<p:sld xmlns:a="http://schemas.openxmlformats.org/drawingml/2006/main" xmlns:p="http://schemas.openxmlformats.org/presentationml/2006/main" xmlns:r="http://schemas.openxmlformats.org/officeDocument/2006/relationships">
+<p:sld xmlns:a="http://schemas.openxmlformats.org/drawingml/2006/main" xmlns:r="http://schemas.openxmlformats.org/officeDocument/2006/relationships" xmlns:p="http://schemas.openxmlformats.org/presentationml/2006/main">
   <p:cSld>
     <p:spTree>
       <p:nvGrpSpPr>
@@ -14755,7 +15641,14 @@
         <p:cNvGrpSpPr/>
         <p:nvPr/>
       </p:nvGrpSpPr>
-      <p:grpSpPr/>
+      <p:grpSpPr>
+        <a:xfrm>
+          <a:off x="0" y="0"/>
+          <a:ext cx="0" cy="0"/>
+          <a:chOff x="0" y="0"/>
+          <a:chExt cx="0" cy="0"/>
+        </a:xfrm>
+      </p:grpSpPr>
       <p:sp>
         <p:nvSpPr>
           <p:cNvPr id="2" name="Title 1"/>
@@ -14824,7 +15717,7 @@
           </a:fontRef>
         </p:style>
         <p:txBody>
-          <a:bodyPr rtlCol="0" anchor="ctr" wrap="square" lIns="76200" rIns="76200" tIns="38100" bIns="38100"/>
+          <a:bodyPr wrap="square" lIns="76200" tIns="38100" rIns="76200" bIns="38100" rtlCol="0" anchor="ctr"/>
           <a:lstStyle/>
           <a:p>
             <a:pPr algn="ctr">
@@ -14887,7 +15780,7 @@
           </a:fontRef>
         </p:style>
         <p:txBody>
-          <a:bodyPr rtlCol="0" anchor="ctr" wrap="square" lIns="76200" rIns="76200" tIns="38100" bIns="38100"/>
+          <a:bodyPr wrap="square" lIns="76200" tIns="38100" rIns="76200" bIns="38100" rtlCol="0" anchor="ctr"/>
           <a:lstStyle/>
           <a:p>
             <a:pPr algn="ctr">
@@ -14953,6 +15846,7 @@
           <a:lstStyle/>
           <a:p>
             <a:pPr algn="ctr"/>
+            <a:endParaRPr/>
           </a:p>
         </p:txBody>
       </p:sp>
@@ -14995,7 +15889,7 @@
           </a:fontRef>
         </p:style>
         <p:txBody>
-          <a:bodyPr rtlCol="0" anchor="ctr" wrap="square" lIns="76200" rIns="76200" tIns="38100" bIns="38100"/>
+          <a:bodyPr wrap="square" lIns="76200" tIns="38100" rIns="76200" bIns="38100" rtlCol="0" anchor="ctr"/>
           <a:lstStyle/>
           <a:p>
             <a:pPr algn="ctr">
@@ -15080,6 +15974,7 @@
           <a:lstStyle/>
           <a:p>
             <a:pPr algn="ctr"/>
+            <a:endParaRPr/>
           </a:p>
         </p:txBody>
       </p:sp>
@@ -15122,7 +16017,7 @@
           </a:fontRef>
         </p:style>
         <p:txBody>
-          <a:bodyPr rtlCol="0" anchor="ctr" wrap="square" lIns="76200" rIns="76200" tIns="38100" bIns="38100"/>
+          <a:bodyPr wrap="square" lIns="76200" tIns="38100" rIns="76200" bIns="38100" rtlCol="0" anchor="ctr"/>
           <a:lstStyle/>
           <a:p>
             <a:pPr algn="ctr">
@@ -15207,6 +16102,7 @@
           <a:lstStyle/>
           <a:p>
             <a:pPr algn="ctr"/>
+            <a:endParaRPr/>
           </a:p>
         </p:txBody>
       </p:sp>
@@ -15249,7 +16145,7 @@
           </a:fontRef>
         </p:style>
         <p:txBody>
-          <a:bodyPr rtlCol="0" anchor="ctr" wrap="square" lIns="76200" rIns="76200" tIns="38100" bIns="38100"/>
+          <a:bodyPr wrap="square" lIns="76200" tIns="38100" rIns="76200" bIns="38100" rtlCol="0" anchor="ctr"/>
           <a:lstStyle/>
           <a:p>
             <a:pPr algn="l">
@@ -15290,7 +16186,7 @@
           <a:noFill/>
         </p:spPr>
         <p:txBody>
-          <a:bodyPr wrap="square" lIns="50800" rIns="50800" tIns="25400" bIns="25400">
+          <a:bodyPr wrap="square" lIns="50800" tIns="25400" rIns="50800" bIns="25400">
             <a:spAutoFit/>
           </a:bodyPr>
           <a:lstStyle/>
@@ -15315,7 +16211,7 @@
             </a:r>
           </a:p>
           <a:p>
-            <a:pPr algn="l" indent="-137160" marL="137160">
+            <a:pPr marL="137160" indent="-137160" algn="l">
               <a:spcBef>
                 <a:spcPts val="200"/>
               </a:spcBef>
@@ -15336,7 +16232,7 @@
             </a:r>
           </a:p>
           <a:p>
-            <a:pPr algn="l" indent="-137160" marL="137160">
+            <a:pPr marL="137160" indent="-137160" algn="l">
               <a:spcBef>
                 <a:spcPts val="200"/>
               </a:spcBef>
@@ -15397,7 +16293,7 @@
           </a:fontRef>
         </p:style>
         <p:txBody>
-          <a:bodyPr rtlCol="0" anchor="ctr" wrap="square" lIns="76200" rIns="76200" tIns="38100" bIns="38100"/>
+          <a:bodyPr wrap="square" lIns="76200" tIns="38100" rIns="76200" bIns="38100" rtlCol="0" anchor="ctr"/>
           <a:lstStyle/>
           <a:p>
             <a:pPr algn="ctr">
@@ -15450,7 +16346,7 @@
 </file>
 
 <file path=ppt/slides/slide9.xml><?xml version="1.0" encoding="utf-8"?>
-<p:sld xmlns:a="http://schemas.openxmlformats.org/drawingml/2006/main" xmlns:p="http://schemas.openxmlformats.org/presentationml/2006/main" xmlns:r="http://schemas.openxmlformats.org/officeDocument/2006/relationships">
+<p:sld xmlns:a="http://schemas.openxmlformats.org/drawingml/2006/main" xmlns:r="http://schemas.openxmlformats.org/officeDocument/2006/relationships" xmlns:p="http://schemas.openxmlformats.org/presentationml/2006/main">
   <p:cSld>
     <p:spTree>
       <p:nvGrpSpPr>
@@ -15458,7 +16354,14 @@
         <p:cNvGrpSpPr/>
         <p:nvPr/>
       </p:nvGrpSpPr>
-      <p:grpSpPr/>
+      <p:grpSpPr>
+        <a:xfrm>
+          <a:off x="0" y="0"/>
+          <a:ext cx="0" cy="0"/>
+          <a:chOff x="0" y="0"/>
+          <a:chExt cx="0" cy="0"/>
+        </a:xfrm>
+      </p:grpSpPr>
       <p:sp>
         <p:nvSpPr>
           <p:cNvPr id="2" name="Title 1"/>
@@ -15527,7 +16430,7 @@
           </a:fontRef>
         </p:style>
         <p:txBody>
-          <a:bodyPr rtlCol="0" anchor="ctr" wrap="square" lIns="76200" rIns="76200" tIns="38100" bIns="38100"/>
+          <a:bodyPr wrap="square" lIns="76200" tIns="38100" rIns="76200" bIns="38100" rtlCol="0" anchor="ctr"/>
           <a:lstStyle/>
           <a:p>
             <a:pPr algn="ctr">
@@ -15568,7 +16471,7 @@
           <a:noFill/>
         </p:spPr>
         <p:txBody>
-          <a:bodyPr wrap="square" lIns="50800" rIns="50800" tIns="25400" bIns="25400">
+          <a:bodyPr wrap="square" lIns="50800" tIns="25400" rIns="50800" bIns="25400">
             <a:spAutoFit/>
           </a:bodyPr>
           <a:lstStyle/>
@@ -15593,7 +16496,7 @@
             </a:r>
           </a:p>
           <a:p>
-            <a:pPr algn="l" indent="-137160" marL="137160">
+            <a:pPr marL="137160" indent="-137160" algn="l">
               <a:spcBef>
                 <a:spcPts val="200"/>
               </a:spcBef>
@@ -15614,7 +16517,7 @@
             </a:r>
           </a:p>
           <a:p>
-            <a:pPr algn="l" indent="-137160" marL="137160">
+            <a:pPr marL="137160" indent="-137160" algn="l">
               <a:spcBef>
                 <a:spcPts val="200"/>
               </a:spcBef>
@@ -15635,7 +16538,7 @@
             </a:r>
           </a:p>
           <a:p>
-            <a:pPr algn="l" indent="-137160" marL="137160">
+            <a:pPr marL="137160" indent="-137160" algn="l">
               <a:spcBef>
                 <a:spcPts val="200"/>
               </a:spcBef>
@@ -15698,7 +16601,7 @@
           </a:fontRef>
         </p:style>
         <p:txBody>
-          <a:bodyPr rtlCol="0" anchor="ctr" wrap="square" lIns="76200" rIns="76200" tIns="38100" bIns="38100"/>
+          <a:bodyPr wrap="square" lIns="76200" tIns="38100" rIns="76200" bIns="38100" rtlCol="0" anchor="ctr"/>
           <a:lstStyle/>
           <a:p>
             <a:pPr algn="ctr">
@@ -15803,7 +16706,7 @@
           </a:fontRef>
         </p:style>
         <p:txBody>
-          <a:bodyPr rtlCol="0" anchor="ctr" wrap="square" lIns="76200" rIns="76200" tIns="38100" bIns="38100"/>
+          <a:bodyPr wrap="square" lIns="76200" tIns="38100" rIns="76200" bIns="38100" rtlCol="0" anchor="ctr"/>
           <a:lstStyle/>
           <a:p>
             <a:pPr algn="ctr">
@@ -15906,7 +16809,7 @@
           </a:fontRef>
         </p:style>
         <p:txBody>
-          <a:bodyPr rtlCol="0" anchor="ctr" wrap="square" lIns="76200" rIns="76200" tIns="38100" bIns="38100"/>
+          <a:bodyPr wrap="square" lIns="76200" tIns="38100" rIns="76200" bIns="38100" rtlCol="0" anchor="ctr"/>
           <a:lstStyle/>
           <a:p>
             <a:pPr algn="ctr">
@@ -15976,7 +16879,7 @@
           <a:noFill/>
         </p:spPr>
         <p:txBody>
-          <a:bodyPr wrap="square" lIns="50800" rIns="50800" tIns="25400" bIns="25400">
+          <a:bodyPr wrap="square" lIns="50800" tIns="25400" rIns="50800" bIns="25400">
             <a:spAutoFit/>
           </a:bodyPr>
           <a:lstStyle/>

</xml_diff>